<commit_message>
feat: finalize submission safety and evidence
</commit_message>
<xml_diff>
--- a/submission/crowd-excess-pitch-deck.pptx
+++ b/submission/crowd-excess-pitch-deck.pptx
@@ -2,21 +2,21 @@
 <file path=ppt/presentation.xml><?xml version="1.0" encoding="utf-8"?>
 <p:presentation xmlns:p="http://schemas.openxmlformats.org/presentationml/2006/main">
   <p:sldMasterIdLst>
-    <p:sldMasterId xmlns:r="http://schemas.openxmlformats.org/officeDocument/2006/relationships" id="2147483648" r:id="Rcb6a9bce53be41ff"/>
+    <p:sldMasterId xmlns:r="http://schemas.openxmlformats.org/officeDocument/2006/relationships" id="2147483648" r:id="R86bc34bce21a49b4"/>
   </p:sldMasterIdLst>
   <p:notesMasterIdLst>
-    <p:notesMasterId xmlns:r="http://schemas.openxmlformats.org/officeDocument/2006/relationships" r:id="R3b810314f001430a"/>
+    <p:notesMasterId xmlns:r="http://schemas.openxmlformats.org/officeDocument/2006/relationships" r:id="R1977725c05344582"/>
   </p:notesMasterIdLst>
   <p:sldIdLst>
-    <p:sldId xmlns:r="http://schemas.openxmlformats.org/officeDocument/2006/relationships" id="256" r:id="Rf716abeb72c142d9"/>
-    <p:sldId xmlns:r="http://schemas.openxmlformats.org/officeDocument/2006/relationships" id="257" r:id="Rf9cda5a2d0034123"/>
-    <p:sldId xmlns:r="http://schemas.openxmlformats.org/officeDocument/2006/relationships" id="258" r:id="Rf5221265cfb243d0"/>
-    <p:sldId xmlns:r="http://schemas.openxmlformats.org/officeDocument/2006/relationships" id="259" r:id="R417b8576fbf24ea9"/>
-    <p:sldId xmlns:r="http://schemas.openxmlformats.org/officeDocument/2006/relationships" id="260" r:id="R1c8cdd824963417d"/>
-    <p:sldId xmlns:r="http://schemas.openxmlformats.org/officeDocument/2006/relationships" id="261" r:id="Rb49bf8dcb27a4310"/>
-    <p:sldId xmlns:r="http://schemas.openxmlformats.org/officeDocument/2006/relationships" id="262" r:id="Rd5a1a2c3fb5b48d3"/>
-    <p:sldId xmlns:r="http://schemas.openxmlformats.org/officeDocument/2006/relationships" id="263" r:id="R4bf52278710b473c"/>
-    <p:sldId xmlns:r="http://schemas.openxmlformats.org/officeDocument/2006/relationships" id="264" r:id="Rb0fcf8ebd161455c"/>
+    <p:sldId xmlns:r="http://schemas.openxmlformats.org/officeDocument/2006/relationships" id="256" r:id="R34e27ba0bd8343a9"/>
+    <p:sldId xmlns:r="http://schemas.openxmlformats.org/officeDocument/2006/relationships" id="257" r:id="R2b5d1aaec4ab4b5b"/>
+    <p:sldId xmlns:r="http://schemas.openxmlformats.org/officeDocument/2006/relationships" id="258" r:id="R7b99c392af06443e"/>
+    <p:sldId xmlns:r="http://schemas.openxmlformats.org/officeDocument/2006/relationships" id="259" r:id="R7fd25e90909b4279"/>
+    <p:sldId xmlns:r="http://schemas.openxmlformats.org/officeDocument/2006/relationships" id="260" r:id="Rdfaae9bb877a4515"/>
+    <p:sldId xmlns:r="http://schemas.openxmlformats.org/officeDocument/2006/relationships" id="261" r:id="Rab29d2e2851b4d03"/>
+    <p:sldId xmlns:r="http://schemas.openxmlformats.org/officeDocument/2006/relationships" id="262" r:id="Rb3d4cc14e6a546ac"/>
+    <p:sldId xmlns:r="http://schemas.openxmlformats.org/officeDocument/2006/relationships" id="263" r:id="Rcf3655dd4a9643b9"/>
+    <p:sldId xmlns:r="http://schemas.openxmlformats.org/officeDocument/2006/relationships" id="264" r:id="R3872e019cb2b459e"/>
   </p:sldIdLst>
   <p:sldSz cx="12192000" cy="6858000"/>
   <p:notesSz cx="6858000" cy="9144000"/>
@@ -805,7 +805,7 @@
           <a:lstStyle xmlns:a="http://schemas.openxmlformats.org/drawingml/2006/main"/>
           <a:p xmlns:a="http://schemas.openxmlformats.org/drawingml/2006/main">
             <a:r>
-              <a:t>Use the live Vercel application. Point out that visitors can inspect but cannot trigger scans or orders.</a:t>
+              <a:t>Show the public Overview, then use Open latest sampled run to enter the immutable trace.</a:t>
             </a:r>
           </a:p>
           <a:p xmlns:a="http://schemas.openxmlformats.org/drawingml/2006/main">
@@ -821,6 +821,11 @@
           <a:p xmlns:a="http://schemas.openxmlformats.org/drawingml/2006/main">
             <a:r>
               <a:t>- https://crowd-excess-lab.vercel.app/agent</a:t>
+            </a:r>
+          </a:p>
+          <a:p xmlns:a="http://schemas.openxmlformats.org/drawingml/2006/main">
+            <a:r>
+              <a:t>- https://crowd-excess-lab.vercel.app/decisions?run=20260828T193701Z-b404b62a</a:t>
             </a:r>
           </a:p>
         </p:txBody>
@@ -980,7 +985,7 @@
           <a:lstStyle xmlns:a="http://schemas.openxmlformats.org/drawingml/2006/main"/>
           <a:p xmlns:a="http://schemas.openxmlformats.org/drawingml/2006/main">
             <a:r>
-              <a:t>Be explicit: this is real infrastructure evidence but not a trading result. Never imply P&amp;L exists yet.</a:t>
+              <a:t>State the verified result exactly: seven market-open shadow scans, five symbols each, no order and no position.</a:t>
             </a:r>
           </a:p>
           <a:p xmlns:a="http://schemas.openxmlformats.org/drawingml/2006/main">
@@ -995,12 +1000,17 @@
           </a:p>
           <a:p xmlns:a="http://schemas.openxmlformats.org/drawingml/2006/main">
             <a:r>
-              <a:t>- https://crowd-excess-lab.vercel.app/agent/runs/20260828T095104Z-cabc99f1</a:t>
-            </a:r>
-          </a:p>
-          <a:p xmlns:a="http://schemas.openxmlformats.org/drawingml/2006/main">
-            <a:r>
-              <a:t>- https://docs.alpaca.markets/us/docs/paper-trading</a:t>
+              <a:t>- https://crowd-excess-lab.vercel.app/api/v1/agent/runs</a:t>
+            </a:r>
+          </a:p>
+          <a:p xmlns:a="http://schemas.openxmlformats.org/drawingml/2006/main">
+            <a:r>
+              <a:t>- https://crowd-excess-lab.vercel.app/api/v1/portfolio</a:t>
+            </a:r>
+          </a:p>
+          <a:p xmlns:a="http://schemas.openxmlformats.org/drawingml/2006/main">
+            <a:r>
+              <a:t>- https://crowd-excess-lab.vercel.app/agent/runs/20260828T193701Z-b404b62a</a:t>
             </a:r>
           </a:p>
         </p:txBody>
@@ -1070,7 +1080,7 @@
           <a:lstStyle xmlns:a="http://schemas.openxmlformats.org/drawingml/2006/main"/>
           <a:p xmlns:a="http://schemas.openxmlformats.org/drawingml/2006/main">
             <a:r>
-              <a:t>Connect resilience to judge trust. Mention the public interface has GET-only projections and zero order controls.</a:t>
+              <a:t>Explain that new provider-boundary failures record sanitized stage/code diagnostics; this historical failure row predates those nullable fields.</a:t>
             </a:r>
           </a:p>
           <a:p xmlns:a="http://schemas.openxmlformats.org/drawingml/2006/main">
@@ -1090,7 +1100,12 @@
           </a:p>
           <a:p xmlns:a="http://schemas.openxmlformats.org/drawingml/2006/main">
             <a:r>
-              <a:t>- https://crowd-excess-lab.vercel.app/lineage</a:t>
+              <a:t>- https://docs.github.com/en/actions/reference/workflows-and-actions/events-that-trigger-workflows#schedule</a:t>
+            </a:r>
+          </a:p>
+          <a:p xmlns:a="http://schemas.openxmlformats.org/drawingml/2006/main">
+            <a:r>
+              <a:t>- https://crowd-excess-lab.vercel.app/agent/runs/20260828T174442Z-d761e38b</a:t>
             </a:r>
           </a:p>
         </p:txBody>
@@ -1160,7 +1175,7 @@
           <a:lstStyle xmlns:a="http://schemas.openxmlformats.org/drawingml/2006/main"/>
           <a:p xmlns:a="http://schemas.openxmlformats.org/drawingml/2006/main">
             <a:r>
-              <a:t>Close with the evidence plan. The system is ready; the remaining uncertainty is market behavior, not infrastructure.</a:t>
+              <a:t>Close on the user value: inspectability before exposure and reproducible abstention when evidence is insufficient.</a:t>
             </a:r>
           </a:p>
           <a:p xmlns:a="http://schemas.openxmlformats.org/drawingml/2006/main">
@@ -1180,7 +1195,12 @@
           </a:p>
           <a:p xmlns:a="http://schemas.openxmlformats.org/drawingml/2006/main">
             <a:r>
-              <a:t>- https://crowd-excess-lab.vercel.app/agent</a:t>
+              <a:t>- https://crowd-excess-lab.vercel.app/strategy</a:t>
+            </a:r>
+          </a:p>
+          <a:p xmlns:a="http://schemas.openxmlformats.org/drawingml/2006/main">
+            <a:r>
+              <a:t>- https://crowd-excess-lab.vercel.app/research</a:t>
             </a:r>
           </a:p>
         </p:txBody>
@@ -1248,7 +1268,7 @@
   </p:cSld>
   <p:clrMap bg1="lt1" tx1="dk1" bg2="lt2" tx2="dk2" accent1="accent1" accent2="accent2" accent3="accent3" accent4="accent4" accent5="accent5" accent6="accent6" hlink="hlink" folHlink="folHlink"/>
   <p:sldLayoutIdLst>
-    <p:sldLayoutId xmlns:r="http://schemas.openxmlformats.org/officeDocument/2006/relationships" id="2147483649" r:id="R7ae40b8d19284462"/>
+    <p:sldLayoutId xmlns:r="http://schemas.openxmlformats.org/officeDocument/2006/relationships" id="2147483649" r:id="R5c24486076624cac"/>
   </p:sldLayoutIdLst>
   <p:txStyles>
     <p:titleStyle>
@@ -1796,7 +1816,7 @@
           <p:nvPr/>
         </p:nvPicPr>
         <p:blipFill>
-          <a:blip xmlns:r="http://schemas.openxmlformats.org/officeDocument/2006/relationships" xmlns:a="http://schemas.openxmlformats.org/drawingml/2006/main" r:embed="Rb4aa693ee5144f39"/>
+          <a:blip xmlns:r="http://schemas.openxmlformats.org/officeDocument/2006/relationships" xmlns:a="http://schemas.openxmlformats.org/drawingml/2006/main" r:embed="R18dd498e454e4fc1"/>
           <a:srcRect xmlns:a="http://schemas.openxmlformats.org/drawingml/2006/main" l="0" t="27" r="0" b="27"/>
           <a:stretch xmlns:a="http://schemas.openxmlformats.org/drawingml/2006/main">
             <a:fillRect l="0" t="0" r="0" b="0"/>
@@ -1874,6 +1894,7 @@
           <a:lstStyle xmlns:a="http://schemas.openxmlformats.org/drawingml/2006/main"/>
           <a:p xmlns:a="http://schemas.openxmlformats.org/drawingml/2006/main">
             <a:pPr algn="l">
+              <a:buNone/>
               <a:defRPr sz="1050" b="1">
                 <a:solidFill>
                   <a:srgbClr val="147A46"/>
@@ -1924,6 +1945,7 @@
           <a:lstStyle xmlns:a="http://schemas.openxmlformats.org/drawingml/2006/main"/>
           <a:p xmlns:a="http://schemas.openxmlformats.org/drawingml/2006/main">
             <a:pPr algn="l">
+              <a:buNone/>
               <a:defRPr sz="3300" b="1">
                 <a:solidFill>
                   <a:srgbClr val="172019"/>
@@ -1974,6 +1996,7 @@
           <a:lstStyle xmlns:a="http://schemas.openxmlformats.org/drawingml/2006/main"/>
           <a:p xmlns:a="http://schemas.openxmlformats.org/drawingml/2006/main">
             <a:pPr algn="l">
+              <a:buNone/>
               <a:defRPr sz="1425" b="0">
                 <a:solidFill>
                   <a:srgbClr val="68736D"/>
@@ -2055,6 +2078,7 @@
           <a:lstStyle xmlns:a="http://schemas.openxmlformats.org/drawingml/2006/main"/>
           <a:p xmlns:a="http://schemas.openxmlformats.org/drawingml/2006/main">
             <a:pPr algn="r">
+              <a:buNone/>
               <a:defRPr sz="975" b="1">
                 <a:solidFill>
                   <a:srgbClr val="68736D"/>
@@ -2105,6 +2129,7 @@
           <a:lstStyle xmlns:a="http://schemas.openxmlformats.org/drawingml/2006/main"/>
           <a:p xmlns:a="http://schemas.openxmlformats.org/drawingml/2006/main">
             <a:pPr algn="l">
+              <a:buNone/>
               <a:defRPr sz="825" b="1">
                 <a:solidFill>
                   <a:srgbClr val="68736D"/>
@@ -2155,6 +2180,7 @@
           <a:lstStyle xmlns:a="http://schemas.openxmlformats.org/drawingml/2006/main"/>
           <a:p xmlns:a="http://schemas.openxmlformats.org/drawingml/2006/main">
             <a:pPr algn="l">
+              <a:buNone/>
               <a:defRPr sz="1350" b="1">
                 <a:solidFill>
                   <a:srgbClr val="147A46"/>
@@ -2205,6 +2231,7 @@
           <a:lstStyle xmlns:a="http://schemas.openxmlformats.org/drawingml/2006/main"/>
           <a:p xmlns:a="http://schemas.openxmlformats.org/drawingml/2006/main">
             <a:pPr algn="l">
+              <a:buNone/>
               <a:defRPr sz="2100" b="1">
                 <a:solidFill>
                   <a:srgbClr val="172019"/>
@@ -2255,6 +2282,7 @@
           <a:lstStyle xmlns:a="http://schemas.openxmlformats.org/drawingml/2006/main"/>
           <a:p xmlns:a="http://schemas.openxmlformats.org/drawingml/2006/main">
             <a:pPr algn="l">
+              <a:buNone/>
               <a:defRPr sz="1350" b="1">
                 <a:solidFill>
                   <a:srgbClr val="929A95"/>
@@ -2305,6 +2333,7 @@
           <a:lstStyle xmlns:a="http://schemas.openxmlformats.org/drawingml/2006/main"/>
           <a:p xmlns:a="http://schemas.openxmlformats.org/drawingml/2006/main">
             <a:pPr algn="l">
+              <a:buNone/>
               <a:defRPr sz="2100" b="1">
                 <a:solidFill>
                   <a:srgbClr val="172019"/>
@@ -2479,6 +2508,7 @@
           <a:lstStyle xmlns:a="http://schemas.openxmlformats.org/drawingml/2006/main"/>
           <a:p xmlns:a="http://schemas.openxmlformats.org/drawingml/2006/main">
             <a:pPr algn="r">
+              <a:buNone/>
               <a:defRPr sz="1650" b="1">
                 <a:solidFill>
                   <a:srgbClr val="147A46"/>
@@ -2529,6 +2559,7 @@
           <a:lstStyle xmlns:a="http://schemas.openxmlformats.org/drawingml/2006/main"/>
           <a:p xmlns:a="http://schemas.openxmlformats.org/drawingml/2006/main">
             <a:pPr algn="l">
+              <a:buNone/>
               <a:defRPr sz="1800" b="0">
                 <a:solidFill>
                   <a:srgbClr val="172019"/>
@@ -2608,6 +2639,7 @@
           <a:lstStyle xmlns:a="http://schemas.openxmlformats.org/drawingml/2006/main"/>
           <a:p xmlns:a="http://schemas.openxmlformats.org/drawingml/2006/main">
             <a:pPr algn="l">
+              <a:buNone/>
               <a:defRPr sz="1050" b="1">
                 <a:solidFill>
                   <a:srgbClr val="147A46"/>
@@ -2658,6 +2690,7 @@
           <a:lstStyle xmlns:a="http://schemas.openxmlformats.org/drawingml/2006/main"/>
           <a:p xmlns:a="http://schemas.openxmlformats.org/drawingml/2006/main">
             <a:pPr algn="l">
+              <a:buNone/>
               <a:defRPr sz="3300" b="1">
                 <a:solidFill>
                   <a:srgbClr val="172019"/>
@@ -2708,6 +2741,7 @@
           <a:lstStyle xmlns:a="http://schemas.openxmlformats.org/drawingml/2006/main"/>
           <a:p xmlns:a="http://schemas.openxmlformats.org/drawingml/2006/main">
             <a:pPr algn="l">
+              <a:buNone/>
               <a:defRPr sz="1425" b="0">
                 <a:solidFill>
                   <a:srgbClr val="68736D"/>
@@ -2789,6 +2823,7 @@
           <a:lstStyle xmlns:a="http://schemas.openxmlformats.org/drawingml/2006/main"/>
           <a:p xmlns:a="http://schemas.openxmlformats.org/drawingml/2006/main">
             <a:pPr algn="r">
+              <a:buNone/>
               <a:defRPr sz="975" b="1">
                 <a:solidFill>
                   <a:srgbClr val="68736D"/>
@@ -2839,6 +2874,7 @@
           <a:lstStyle xmlns:a="http://schemas.openxmlformats.org/drawingml/2006/main"/>
           <a:p xmlns:a="http://schemas.openxmlformats.org/drawingml/2006/main">
             <a:pPr algn="l">
+              <a:buNone/>
               <a:defRPr sz="825" b="1">
                 <a:solidFill>
                   <a:srgbClr val="68736D"/>
@@ -2889,6 +2925,7 @@
           <a:lstStyle xmlns:a="http://schemas.openxmlformats.org/drawingml/2006/main"/>
           <a:p xmlns:a="http://schemas.openxmlformats.org/drawingml/2006/main">
             <a:pPr algn="l">
+              <a:buNone/>
               <a:defRPr sz="2550" b="1">
                 <a:solidFill>
                   <a:srgbClr val="147A46"/>
@@ -2939,6 +2976,7 @@
           <a:lstStyle xmlns:a="http://schemas.openxmlformats.org/drawingml/2006/main"/>
           <a:p xmlns:a="http://schemas.openxmlformats.org/drawingml/2006/main">
             <a:pPr algn="l">
+              <a:buNone/>
               <a:defRPr sz="2100" b="1">
                 <a:solidFill>
                   <a:srgbClr val="172019"/>
@@ -2989,6 +3027,7 @@
           <a:lstStyle xmlns:a="http://schemas.openxmlformats.org/drawingml/2006/main"/>
           <a:p xmlns:a="http://schemas.openxmlformats.org/drawingml/2006/main">
             <a:pPr algn="l">
+              <a:buNone/>
               <a:defRPr sz="1425" b="0">
                 <a:solidFill>
                   <a:srgbClr val="68736D"/>
@@ -3011,6 +3050,7 @@
           </a:p>
           <a:p xmlns:a="http://schemas.openxmlformats.org/drawingml/2006/main">
             <a:pPr algn="l">
+              <a:buNone/>
               <a:defRPr sz="1425" b="0">
                 <a:solidFill>
                   <a:srgbClr val="68736D"/>
@@ -3028,6 +3068,7 @@
           </a:p>
           <a:p xmlns:a="http://schemas.openxmlformats.org/drawingml/2006/main">
             <a:pPr algn="l">
+              <a:buNone/>
               <a:defRPr sz="1425" b="0">
                 <a:solidFill>
                   <a:srgbClr val="68736D"/>
@@ -3109,6 +3150,7 @@
           <a:lstStyle xmlns:a="http://schemas.openxmlformats.org/drawingml/2006/main"/>
           <a:p xmlns:a="http://schemas.openxmlformats.org/drawingml/2006/main">
             <a:pPr algn="l">
+              <a:buNone/>
               <a:defRPr sz="2550" b="1">
                 <a:solidFill>
                   <a:srgbClr val="147A46"/>
@@ -3159,6 +3201,7 @@
           <a:lstStyle xmlns:a="http://schemas.openxmlformats.org/drawingml/2006/main"/>
           <a:p xmlns:a="http://schemas.openxmlformats.org/drawingml/2006/main">
             <a:pPr algn="l">
+              <a:buNone/>
               <a:defRPr sz="2100" b="1">
                 <a:solidFill>
                   <a:srgbClr val="172019"/>
@@ -3209,6 +3252,7 @@
           <a:lstStyle xmlns:a="http://schemas.openxmlformats.org/drawingml/2006/main"/>
           <a:p xmlns:a="http://schemas.openxmlformats.org/drawingml/2006/main">
             <a:pPr algn="l">
+              <a:buNone/>
               <a:defRPr sz="1425" b="0">
                 <a:solidFill>
                   <a:srgbClr val="68736D"/>
@@ -3231,6 +3275,7 @@
           </a:p>
           <a:p xmlns:a="http://schemas.openxmlformats.org/drawingml/2006/main">
             <a:pPr algn="l">
+              <a:buNone/>
               <a:defRPr sz="1425" b="0">
                 <a:solidFill>
                   <a:srgbClr val="68736D"/>
@@ -3312,6 +3357,7 @@
           <a:lstStyle xmlns:a="http://schemas.openxmlformats.org/drawingml/2006/main"/>
           <a:p xmlns:a="http://schemas.openxmlformats.org/drawingml/2006/main">
             <a:pPr algn="l">
+              <a:buNone/>
               <a:defRPr sz="2550" b="1">
                 <a:solidFill>
                   <a:srgbClr val="147A46"/>
@@ -3362,6 +3408,7 @@
           <a:lstStyle xmlns:a="http://schemas.openxmlformats.org/drawingml/2006/main"/>
           <a:p xmlns:a="http://schemas.openxmlformats.org/drawingml/2006/main">
             <a:pPr algn="l">
+              <a:buNone/>
               <a:defRPr sz="2100" b="1">
                 <a:solidFill>
                   <a:srgbClr val="172019"/>
@@ -3412,6 +3459,7 @@
           <a:lstStyle xmlns:a="http://schemas.openxmlformats.org/drawingml/2006/main"/>
           <a:p xmlns:a="http://schemas.openxmlformats.org/drawingml/2006/main">
             <a:pPr algn="l">
+              <a:buNone/>
               <a:defRPr sz="1425" b="0">
                 <a:solidFill>
                   <a:srgbClr val="68736D"/>
@@ -3434,6 +3482,7 @@
           </a:p>
           <a:p xmlns:a="http://schemas.openxmlformats.org/drawingml/2006/main">
             <a:pPr algn="l">
+              <a:buNone/>
               <a:defRPr sz="1425" b="0">
                 <a:solidFill>
                   <a:srgbClr val="68736D"/>
@@ -3451,6 +3500,7 @@
           </a:p>
           <a:p xmlns:a="http://schemas.openxmlformats.org/drawingml/2006/main">
             <a:pPr algn="l">
+              <a:buNone/>
               <a:defRPr sz="1425" b="0">
                 <a:solidFill>
                   <a:srgbClr val="68736D"/>
@@ -3530,6 +3580,7 @@
           <a:lstStyle xmlns:a="http://schemas.openxmlformats.org/drawingml/2006/main"/>
           <a:p xmlns:a="http://schemas.openxmlformats.org/drawingml/2006/main">
             <a:pPr algn="l">
+              <a:buNone/>
               <a:defRPr sz="1050" b="1">
                 <a:solidFill>
                   <a:srgbClr val="147A46"/>
@@ -3580,6 +3631,7 @@
           <a:lstStyle xmlns:a="http://schemas.openxmlformats.org/drawingml/2006/main"/>
           <a:p xmlns:a="http://schemas.openxmlformats.org/drawingml/2006/main">
             <a:pPr algn="l">
+              <a:buNone/>
               <a:defRPr sz="3300" b="1">
                 <a:solidFill>
                   <a:srgbClr val="172019"/>
@@ -3661,6 +3713,7 @@
           <a:lstStyle xmlns:a="http://schemas.openxmlformats.org/drawingml/2006/main"/>
           <a:p xmlns:a="http://schemas.openxmlformats.org/drawingml/2006/main">
             <a:pPr algn="r">
+              <a:buNone/>
               <a:defRPr sz="975" b="1">
                 <a:solidFill>
                   <a:srgbClr val="68736D"/>
@@ -3711,6 +3764,7 @@
           <a:lstStyle xmlns:a="http://schemas.openxmlformats.org/drawingml/2006/main"/>
           <a:p xmlns:a="http://schemas.openxmlformats.org/drawingml/2006/main">
             <a:pPr algn="l">
+              <a:buNone/>
               <a:defRPr sz="825" b="1">
                 <a:solidFill>
                   <a:srgbClr val="68736D"/>
@@ -3761,6 +3815,7 @@
           <a:lstStyle xmlns:a="http://schemas.openxmlformats.org/drawingml/2006/main"/>
           <a:p xmlns:a="http://schemas.openxmlformats.org/drawingml/2006/main">
             <a:pPr algn="l">
+              <a:buNone/>
               <a:defRPr sz="2550" b="1">
                 <a:solidFill>
                   <a:srgbClr val="147A46"/>
@@ -3811,6 +3866,7 @@
           <a:lstStyle xmlns:a="http://schemas.openxmlformats.org/drawingml/2006/main"/>
           <a:p xmlns:a="http://schemas.openxmlformats.org/drawingml/2006/main">
             <a:pPr algn="ctr">
+              <a:buNone/>
               <a:defRPr sz="2850" b="1">
                 <a:solidFill>
                   <a:srgbClr val="68736D"/>
@@ -3861,6 +3917,7 @@
           <a:lstStyle xmlns:a="http://schemas.openxmlformats.org/drawingml/2006/main"/>
           <a:p xmlns:a="http://schemas.openxmlformats.org/drawingml/2006/main">
             <a:pPr algn="l">
+              <a:buNone/>
               <a:defRPr sz="2550" b="1">
                 <a:solidFill>
                   <a:srgbClr val="172019"/>
@@ -3911,6 +3968,7 @@
           <a:lstStyle xmlns:a="http://schemas.openxmlformats.org/drawingml/2006/main"/>
           <a:p xmlns:a="http://schemas.openxmlformats.org/drawingml/2006/main">
             <a:pPr algn="l">
+              <a:buNone/>
               <a:defRPr sz="1875" b="0">
                 <a:solidFill>
                   <a:srgbClr val="68736D"/>
@@ -3992,6 +4050,7 @@
           <a:lstStyle xmlns:a="http://schemas.openxmlformats.org/drawingml/2006/main"/>
           <a:p xmlns:a="http://schemas.openxmlformats.org/drawingml/2006/main">
             <a:pPr algn="l">
+              <a:buNone/>
               <a:defRPr sz="1275" b="1">
                 <a:solidFill>
                   <a:srgbClr val="147A46"/>
@@ -4042,6 +4101,7 @@
           <a:lstStyle xmlns:a="http://schemas.openxmlformats.org/drawingml/2006/main"/>
           <a:p xmlns:a="http://schemas.openxmlformats.org/drawingml/2006/main">
             <a:pPr algn="l">
+              <a:buNone/>
               <a:defRPr sz="1650" b="0">
                 <a:solidFill>
                   <a:srgbClr val="172019"/>
@@ -4092,6 +4152,7 @@
           <a:lstStyle xmlns:a="http://schemas.openxmlformats.org/drawingml/2006/main"/>
           <a:p xmlns:a="http://schemas.openxmlformats.org/drawingml/2006/main">
             <a:pPr algn="l">
+              <a:buNone/>
               <a:defRPr sz="1275" b="1">
                 <a:solidFill>
                   <a:srgbClr val="855900"/>
@@ -4142,6 +4203,7 @@
           <a:lstStyle xmlns:a="http://schemas.openxmlformats.org/drawingml/2006/main"/>
           <a:p xmlns:a="http://schemas.openxmlformats.org/drawingml/2006/main">
             <a:pPr algn="l">
+              <a:buNone/>
               <a:defRPr sz="1650" b="0">
                 <a:solidFill>
                   <a:srgbClr val="172019"/>
@@ -4192,6 +4254,7 @@
           <a:lstStyle xmlns:a="http://schemas.openxmlformats.org/drawingml/2006/main"/>
           <a:p xmlns:a="http://schemas.openxmlformats.org/drawingml/2006/main">
             <a:pPr algn="l">
+              <a:buNone/>
               <a:defRPr sz="1500" b="1">
                 <a:solidFill>
                   <a:srgbClr val="147A46"/>
@@ -4271,6 +4334,7 @@
           <a:lstStyle xmlns:a="http://schemas.openxmlformats.org/drawingml/2006/main"/>
           <a:p xmlns:a="http://schemas.openxmlformats.org/drawingml/2006/main">
             <a:pPr algn="l">
+              <a:buNone/>
               <a:defRPr sz="1050" b="1">
                 <a:solidFill>
                   <a:srgbClr val="147A46"/>
@@ -4321,6 +4385,7 @@
           <a:lstStyle xmlns:a="http://schemas.openxmlformats.org/drawingml/2006/main"/>
           <a:p xmlns:a="http://schemas.openxmlformats.org/drawingml/2006/main">
             <a:pPr algn="l">
+              <a:buNone/>
               <a:defRPr sz="3300" b="1">
                 <a:solidFill>
                   <a:srgbClr val="172019"/>
@@ -4333,7 +4398,7 @@
                   <a:srgbClr val="172019"/>
                 </a:solidFill>
               </a:rPr>
-              <a:t>One screen makes the entire decision inspectable.</a:t>
+              <a:t>Every decision becomes an auditable trace.</a:t>
             </a:r>
           </a:p>
         </p:txBody>
@@ -4402,6 +4467,7 @@
           <a:lstStyle xmlns:a="http://schemas.openxmlformats.org/drawingml/2006/main"/>
           <a:p xmlns:a="http://schemas.openxmlformats.org/drawingml/2006/main">
             <a:pPr algn="r">
+              <a:buNone/>
               <a:defRPr sz="975" b="1">
                 <a:solidFill>
                   <a:srgbClr val="68736D"/>
@@ -4452,6 +4518,7 @@
           <a:lstStyle xmlns:a="http://schemas.openxmlformats.org/drawingml/2006/main"/>
           <a:p xmlns:a="http://schemas.openxmlformats.org/drawingml/2006/main">
             <a:pPr algn="l">
+              <a:buNone/>
               <a:defRPr sz="825" b="1">
                 <a:solidFill>
                   <a:srgbClr val="68736D"/>
@@ -4471,25 +4538,23 @@
       </p:sp>
       <p:pic>
         <p:nvPicPr>
-          <p:cNvPr id="18" name=""/>
+          <p:cNvPr id="20" name=""/>
           <p:cNvPicPr>
             <a:picLocks xmlns:a="http://schemas.openxmlformats.org/drawingml/2006/main" noChangeAspect="1"/>
           </p:cNvPicPr>
           <p:nvPr/>
         </p:nvPicPr>
         <p:blipFill>
-          <a:blip xmlns:r="http://schemas.openxmlformats.org/officeDocument/2006/relationships" xmlns:a="http://schemas.openxmlformats.org/drawingml/2006/main" r:embed="R43f5ec3a31f94103"/>
+          <a:blip xmlns:r="http://schemas.openxmlformats.org/officeDocument/2006/relationships" xmlns:a="http://schemas.openxmlformats.org/drawingml/2006/main" r:embed="Rc669f431c5df46ab"/>
           <a:stretch xmlns:a="http://schemas.openxmlformats.org/drawingml/2006/main"/>
         </p:blipFill>
         <p:spPr>
-          <a:xfrm xmlns:a="http://schemas.openxmlformats.org/drawingml/2006/main">
+          <a:xfrm xmlns:a="http://schemas.openxmlformats.org/drawingml/2006/main" flipH="0" flipV="0">
             <a:off x="1409700" y="1952625"/>
             <a:ext cx="6781800" cy="4238625"/>
           </a:xfrm>
           <a:prstGeom xmlns:a="http://schemas.openxmlformats.org/drawingml/2006/main" prst="roundRect">
-            <a:avLst>
-              <a:gd name="adj" fmla="val 2247"/>
-            </a:avLst>
+            <a:avLst/>
           </a:prstGeom>
         </p:spPr>
       </p:pic>
@@ -4526,6 +4591,7 @@
           <a:lstStyle xmlns:a="http://schemas.openxmlformats.org/drawingml/2006/main"/>
           <a:p xmlns:a="http://schemas.openxmlformats.org/drawingml/2006/main">
             <a:pPr algn="l">
+              <a:buNone/>
               <a:defRPr sz="2100" b="1">
                 <a:solidFill>
                   <a:srgbClr val="147A46"/>
@@ -4576,6 +4642,7 @@
           <a:lstStyle xmlns:a="http://schemas.openxmlformats.org/drawingml/2006/main"/>
           <a:p xmlns:a="http://schemas.openxmlformats.org/drawingml/2006/main">
             <a:pPr algn="l">
+              <a:buNone/>
               <a:defRPr sz="1575" b="1">
                 <a:solidFill>
                   <a:srgbClr val="172019"/>
@@ -4588,7 +4655,7 @@
                   <a:srgbClr val="172019"/>
                 </a:solidFill>
               </a:rPr>
-              <a:t>Run tape</a:t>
+              <a:t>Latest check</a:t>
             </a:r>
           </a:p>
         </p:txBody>
@@ -4626,6 +4693,7 @@
           <a:lstStyle xmlns:a="http://schemas.openxmlformats.org/drawingml/2006/main"/>
           <a:p xmlns:a="http://schemas.openxmlformats.org/drawingml/2006/main">
             <a:pPr algn="l">
+              <a:buNone/>
               <a:defRPr sz="2100" b="1">
                 <a:solidFill>
                   <a:srgbClr val="147A46"/>
@@ -4676,6 +4744,7 @@
           <a:lstStyle xmlns:a="http://schemas.openxmlformats.org/drawingml/2006/main"/>
           <a:p xmlns:a="http://schemas.openxmlformats.org/drawingml/2006/main">
             <a:pPr algn="l">
+              <a:buNone/>
               <a:defRPr sz="1575" b="1">
                 <a:solidFill>
                   <a:srgbClr val="172019"/>
@@ -4688,7 +4757,7 @@
                   <a:srgbClr val="172019"/>
                 </a:solidFill>
               </a:rPr>
-              <a:t>Signal matrix</a:t>
+              <a:t>Latest sampled run</a:t>
             </a:r>
           </a:p>
         </p:txBody>
@@ -4726,6 +4795,7 @@
           <a:lstStyle xmlns:a="http://schemas.openxmlformats.org/drawingml/2006/main"/>
           <a:p xmlns:a="http://schemas.openxmlformats.org/drawingml/2006/main">
             <a:pPr algn="l">
+              <a:buNone/>
               <a:defRPr sz="2100" b="1">
                 <a:solidFill>
                   <a:srgbClr val="147A46"/>
@@ -4776,6 +4846,7 @@
           <a:lstStyle xmlns:a="http://schemas.openxmlformats.org/drawingml/2006/main"/>
           <a:p xmlns:a="http://schemas.openxmlformats.org/drawingml/2006/main">
             <a:pPr algn="l">
+              <a:buNone/>
               <a:defRPr sz="1575" b="1">
                 <a:solidFill>
                   <a:srgbClr val="172019"/>
@@ -4788,7 +4859,7 @@
                   <a:srgbClr val="172019"/>
                 </a:solidFill>
               </a:rPr>
-              <a:t>Evidence → risk → receipt</a:t>
+              <a:t>Evidence -&gt; risk -&gt; outcome</a:t>
             </a:r>
           </a:p>
         </p:txBody>
@@ -4855,6 +4926,7 @@
           <a:lstStyle xmlns:a="http://schemas.openxmlformats.org/drawingml/2006/main"/>
           <a:p xmlns:a="http://schemas.openxmlformats.org/drawingml/2006/main">
             <a:pPr algn="l">
+              <a:buNone/>
               <a:defRPr sz="1050" b="1">
                 <a:solidFill>
                   <a:srgbClr val="147A46"/>
@@ -4905,6 +4977,7 @@
           <a:lstStyle xmlns:a="http://schemas.openxmlformats.org/drawingml/2006/main"/>
           <a:p xmlns:a="http://schemas.openxmlformats.org/drawingml/2006/main">
             <a:pPr algn="l">
+              <a:buNone/>
               <a:defRPr sz="3300" b="1">
                 <a:solidFill>
                   <a:srgbClr val="172019"/>
@@ -4986,6 +5059,7 @@
           <a:lstStyle xmlns:a="http://schemas.openxmlformats.org/drawingml/2006/main"/>
           <a:p xmlns:a="http://schemas.openxmlformats.org/drawingml/2006/main">
             <a:pPr algn="r">
+              <a:buNone/>
               <a:defRPr sz="975" b="1">
                 <a:solidFill>
                   <a:srgbClr val="68736D"/>
@@ -5036,6 +5110,7 @@
           <a:lstStyle xmlns:a="http://schemas.openxmlformats.org/drawingml/2006/main"/>
           <a:p xmlns:a="http://schemas.openxmlformats.org/drawingml/2006/main">
             <a:pPr algn="l">
+              <a:buNone/>
               <a:defRPr sz="825" b="1">
                 <a:solidFill>
                   <a:srgbClr val="68736D"/>
@@ -5086,6 +5161,7 @@
           <a:lstStyle xmlns:a="http://schemas.openxmlformats.org/drawingml/2006/main"/>
           <a:p xmlns:a="http://schemas.openxmlformats.org/drawingml/2006/main">
             <a:pPr algn="l">
+              <a:buNone/>
               <a:defRPr sz="4050" b="1">
                 <a:solidFill>
                   <a:srgbClr val="147A46"/>
@@ -5136,6 +5212,7 @@
           <a:lstStyle xmlns:a="http://schemas.openxmlformats.org/drawingml/2006/main"/>
           <a:p xmlns:a="http://schemas.openxmlformats.org/drawingml/2006/main">
             <a:pPr algn="l">
+              <a:buNone/>
               <a:defRPr sz="1200" b="1">
                 <a:solidFill>
                   <a:srgbClr val="172019"/>
@@ -5186,6 +5263,7 @@
           <a:lstStyle xmlns:a="http://schemas.openxmlformats.org/drawingml/2006/main"/>
           <a:p xmlns:a="http://schemas.openxmlformats.org/drawingml/2006/main">
             <a:pPr algn="l">
+              <a:buNone/>
               <a:defRPr sz="1275" b="0">
                 <a:solidFill>
                   <a:srgbClr val="68736D"/>
@@ -5236,6 +5314,7 @@
           <a:lstStyle xmlns:a="http://schemas.openxmlformats.org/drawingml/2006/main"/>
           <a:p xmlns:a="http://schemas.openxmlformats.org/drawingml/2006/main">
             <a:pPr algn="l">
+              <a:buNone/>
               <a:defRPr sz="4050" b="1">
                 <a:solidFill>
                   <a:srgbClr val="147A46"/>
@@ -5286,6 +5365,7 @@
           <a:lstStyle xmlns:a="http://schemas.openxmlformats.org/drawingml/2006/main"/>
           <a:p xmlns:a="http://schemas.openxmlformats.org/drawingml/2006/main">
             <a:pPr algn="l">
+              <a:buNone/>
               <a:defRPr sz="1200" b="1">
                 <a:solidFill>
                   <a:srgbClr val="172019"/>
@@ -5336,6 +5416,7 @@
           <a:lstStyle xmlns:a="http://schemas.openxmlformats.org/drawingml/2006/main"/>
           <a:p xmlns:a="http://schemas.openxmlformats.org/drawingml/2006/main">
             <a:pPr algn="l">
+              <a:buNone/>
               <a:defRPr sz="1275" b="0">
                 <a:solidFill>
                   <a:srgbClr val="68736D"/>
@@ -5386,6 +5467,7 @@
           <a:lstStyle xmlns:a="http://schemas.openxmlformats.org/drawingml/2006/main"/>
           <a:p xmlns:a="http://schemas.openxmlformats.org/drawingml/2006/main">
             <a:pPr algn="l">
+              <a:buNone/>
               <a:defRPr sz="4050" b="1">
                 <a:solidFill>
                   <a:srgbClr val="147A46"/>
@@ -5436,6 +5518,7 @@
           <a:lstStyle xmlns:a="http://schemas.openxmlformats.org/drawingml/2006/main"/>
           <a:p xmlns:a="http://schemas.openxmlformats.org/drawingml/2006/main">
             <a:pPr algn="l">
+              <a:buNone/>
               <a:defRPr sz="1200" b="1">
                 <a:solidFill>
                   <a:srgbClr val="172019"/>
@@ -5486,6 +5569,7 @@
           <a:lstStyle xmlns:a="http://schemas.openxmlformats.org/drawingml/2006/main"/>
           <a:p xmlns:a="http://schemas.openxmlformats.org/drawingml/2006/main">
             <a:pPr algn="l">
+              <a:buNone/>
               <a:defRPr sz="1275" b="0">
                 <a:solidFill>
                   <a:srgbClr val="68736D"/>
@@ -5536,6 +5620,7 @@
           <a:lstStyle xmlns:a="http://schemas.openxmlformats.org/drawingml/2006/main"/>
           <a:p xmlns:a="http://schemas.openxmlformats.org/drawingml/2006/main">
             <a:pPr algn="l">
+              <a:buNone/>
               <a:defRPr sz="4050" b="1">
                 <a:solidFill>
                   <a:srgbClr val="147A46"/>
@@ -5586,6 +5671,7 @@
           <a:lstStyle xmlns:a="http://schemas.openxmlformats.org/drawingml/2006/main"/>
           <a:p xmlns:a="http://schemas.openxmlformats.org/drawingml/2006/main">
             <a:pPr algn="l">
+              <a:buNone/>
               <a:defRPr sz="1200" b="1">
                 <a:solidFill>
                   <a:srgbClr val="172019"/>
@@ -5636,6 +5722,7 @@
           <a:lstStyle xmlns:a="http://schemas.openxmlformats.org/drawingml/2006/main"/>
           <a:p xmlns:a="http://schemas.openxmlformats.org/drawingml/2006/main">
             <a:pPr algn="l">
+              <a:buNone/>
               <a:defRPr sz="1275" b="0">
                 <a:solidFill>
                   <a:srgbClr val="68736D"/>
@@ -5717,6 +5804,7 @@
           <a:lstStyle xmlns:a="http://schemas.openxmlformats.org/drawingml/2006/main"/>
           <a:p xmlns:a="http://schemas.openxmlformats.org/drawingml/2006/main">
             <a:pPr algn="l">
+              <a:buNone/>
               <a:defRPr sz="1575" b="1">
                 <a:solidFill>
                   <a:srgbClr val="172019"/>
@@ -5767,6 +5855,7 @@
           <a:lstStyle xmlns:a="http://schemas.openxmlformats.org/drawingml/2006/main"/>
           <a:p xmlns:a="http://schemas.openxmlformats.org/drawingml/2006/main">
             <a:pPr algn="l">
+              <a:buNone/>
               <a:defRPr sz="1575" b="1">
                 <a:solidFill>
                   <a:srgbClr val="172019"/>
@@ -5817,6 +5906,7 @@
           <a:lstStyle xmlns:a="http://schemas.openxmlformats.org/drawingml/2006/main"/>
           <a:p xmlns:a="http://schemas.openxmlformats.org/drawingml/2006/main">
             <a:pPr algn="l">
+              <a:buNone/>
               <a:defRPr sz="1575" b="1">
                 <a:solidFill>
                   <a:srgbClr val="172019"/>
@@ -5867,6 +5957,7 @@
           <a:lstStyle xmlns:a="http://schemas.openxmlformats.org/drawingml/2006/main"/>
           <a:p xmlns:a="http://schemas.openxmlformats.org/drawingml/2006/main">
             <a:pPr algn="l">
+              <a:buNone/>
               <a:defRPr sz="1575" b="0">
                 <a:solidFill>
                   <a:srgbClr val="68736D"/>
@@ -5946,6 +6037,7 @@
           <a:lstStyle xmlns:a="http://schemas.openxmlformats.org/drawingml/2006/main"/>
           <a:p xmlns:a="http://schemas.openxmlformats.org/drawingml/2006/main">
             <a:pPr algn="l">
+              <a:buNone/>
               <a:defRPr sz="1050" b="1">
                 <a:solidFill>
                   <a:srgbClr val="147A46"/>
@@ -5996,6 +6088,7 @@
           <a:lstStyle xmlns:a="http://schemas.openxmlformats.org/drawingml/2006/main"/>
           <a:p xmlns:a="http://schemas.openxmlformats.org/drawingml/2006/main">
             <a:pPr algn="l">
+              <a:buNone/>
               <a:defRPr sz="3300" b="1">
                 <a:solidFill>
                   <a:srgbClr val="172019"/>
@@ -6008,7 +6101,7 @@
                   <a:srgbClr val="172019"/>
                 </a:solidFill>
               </a:rPr>
-              <a:t>The first real result was a safe no-trade.</a:t>
+              <a:t>Seven market-open scans protected capital.</a:t>
             </a:r>
           </a:p>
         </p:txBody>
@@ -6046,6 +6139,7 @@
           <a:lstStyle xmlns:a="http://schemas.openxmlformats.org/drawingml/2006/main"/>
           <a:p xmlns:a="http://schemas.openxmlformats.org/drawingml/2006/main">
             <a:pPr algn="l">
+              <a:buNone/>
               <a:defRPr sz="1425" b="0">
                 <a:solidFill>
                   <a:srgbClr val="68736D"/>
@@ -6058,7 +6152,7 @@
                   <a:srgbClr val="68736D"/>
                 </a:solidFill>
               </a:rPr>
-              <a:t>Pre-kickoff infrastructure verification · not competition P&amp;L</a:t>
+              <a:t>Competition evidence | 28 Aug 2026 US session</a:t>
             </a:r>
           </a:p>
         </p:txBody>
@@ -6127,6 +6221,7 @@
           <a:lstStyle xmlns:a="http://schemas.openxmlformats.org/drawingml/2006/main"/>
           <a:p xmlns:a="http://schemas.openxmlformats.org/drawingml/2006/main">
             <a:pPr algn="r">
+              <a:buNone/>
               <a:defRPr sz="975" b="1">
                 <a:solidFill>
                   <a:srgbClr val="68736D"/>
@@ -6177,6 +6272,7 @@
           <a:lstStyle xmlns:a="http://schemas.openxmlformats.org/drawingml/2006/main"/>
           <a:p xmlns:a="http://schemas.openxmlformats.org/drawingml/2006/main">
             <a:pPr algn="l">
+              <a:buNone/>
               <a:defRPr sz="825" b="1">
                 <a:solidFill>
                   <a:srgbClr val="68736D"/>
@@ -6227,6 +6323,7 @@
           <a:lstStyle xmlns:a="http://schemas.openxmlformats.org/drawingml/2006/main"/>
           <a:p xmlns:a="http://schemas.openxmlformats.org/drawingml/2006/main">
             <a:pPr algn="l">
+              <a:buNone/>
               <a:defRPr sz="4350" b="1">
                 <a:solidFill>
                   <a:srgbClr val="855900"/>
@@ -6239,7 +6336,7 @@
                   <a:srgbClr val="855900"/>
                 </a:solidFill>
               </a:rPr>
-              <a:t>ABSTAINED</a:t>
+              <a:t>7 x 5</a:t>
             </a:r>
           </a:p>
         </p:txBody>
@@ -6277,6 +6374,7 @@
           <a:lstStyle xmlns:a="http://schemas.openxmlformats.org/drawingml/2006/main"/>
           <a:p xmlns:a="http://schemas.openxmlformats.org/drawingml/2006/main">
             <a:pPr algn="l">
+              <a:buNone/>
               <a:defRPr sz="1800" b="1">
                 <a:solidFill>
                   <a:srgbClr val="172019"/>
@@ -6289,7 +6387,7 @@
                   <a:srgbClr val="172019"/>
                 </a:solidFill>
               </a:rPr>
-              <a:t>Market clock closed</a:t>
+              <a:t>SCANS x SYMBOLS</a:t>
             </a:r>
           </a:p>
         </p:txBody>
@@ -6327,6 +6425,7 @@
           <a:lstStyle xmlns:a="http://schemas.openxmlformats.org/drawingml/2006/main"/>
           <a:p xmlns:a="http://schemas.openxmlformats.org/drawingml/2006/main">
             <a:pPr algn="l">
+              <a:buNone/>
               <a:defRPr sz="1575" b="0">
                 <a:solidFill>
                   <a:srgbClr val="68736D"/>
@@ -6339,7 +6438,7 @@
                   <a:srgbClr val="68736D"/>
                 </a:solidFill>
               </a:rPr>
-              <a:t>No scan. No order. No fabricated signal.</a:t>
+              <a:t>35 structured evidence assessments</a:t>
             </a:r>
           </a:p>
         </p:txBody>
@@ -6412,6 +6511,7 @@
           <a:lstStyle xmlns:a="http://schemas.openxmlformats.org/drawingml/2006/main"/>
           <a:p xmlns:a="http://schemas.openxmlformats.org/drawingml/2006/main">
             <a:pPr algn="l">
+              <a:buNone/>
               <a:defRPr sz="3600" b="1">
                 <a:solidFill>
                   <a:srgbClr val="147A46"/>
@@ -6462,6 +6562,7 @@
           <a:lstStyle xmlns:a="http://schemas.openxmlformats.org/drawingml/2006/main"/>
           <a:p xmlns:a="http://schemas.openxmlformats.org/drawingml/2006/main">
             <a:pPr algn="l">
+              <a:buNone/>
               <a:defRPr sz="1275" b="1">
                 <a:solidFill>
                   <a:srgbClr val="172019"/>
@@ -6474,7 +6575,7 @@
                   <a:srgbClr val="172019"/>
                 </a:solidFill>
               </a:rPr>
-              <a:t>ACTIVE ALPACA PAPER ACCOUNT</a:t>
+              <a:t>EQUITY | $0 P&amp;L | 0 DRAWDOWN</a:t>
             </a:r>
           </a:p>
         </p:txBody>
@@ -6512,6 +6613,7 @@
           <a:lstStyle xmlns:a="http://schemas.openxmlformats.org/drawingml/2006/main"/>
           <a:p xmlns:a="http://schemas.openxmlformats.org/drawingml/2006/main">
             <a:pPr algn="l">
+              <a:buNone/>
               <a:defRPr sz="1200" b="0">
                 <a:solidFill>
                   <a:srgbClr val="68736D"/>
@@ -6524,7 +6626,7 @@
                   <a:srgbClr val="68736D"/>
                 </a:solidFill>
               </a:rPr>
-              <a:t>Run 20260828T095104Z-cabc99f1</a:t>
+              <a:t>0 positions | 0 open risk</a:t>
             </a:r>
           </a:p>
         </p:txBody>
@@ -6562,6 +6664,7 @@
           <a:lstStyle xmlns:a="http://schemas.openxmlformats.org/drawingml/2006/main"/>
           <a:p xmlns:a="http://schemas.openxmlformats.org/drawingml/2006/main">
             <a:pPr algn="l">
+              <a:buNone/>
               <a:defRPr sz="1275" b="1">
                 <a:solidFill>
                   <a:srgbClr val="147A46"/>
@@ -6574,7 +6677,7 @@
                   <a:srgbClr val="147A46"/>
                 </a:solidFill>
               </a:rPr>
-              <a:t>Append-only public trace</a:t>
+              <a:t>No forced trade</a:t>
             </a:r>
           </a:p>
         </p:txBody>
@@ -6612,6 +6715,7 @@
           <a:lstStyle xmlns:a="http://schemas.openxmlformats.org/drawingml/2006/main"/>
           <a:p xmlns:a="http://schemas.openxmlformats.org/drawingml/2006/main">
             <a:pPr algn="l">
+              <a:buNone/>
               <a:defRPr sz="1650" b="1">
                 <a:solidFill>
                   <a:srgbClr val="172019"/>
@@ -6624,7 +6728,7 @@
                   <a:srgbClr val="172019"/>
                 </a:solidFill>
               </a:rPr>
-              <a:t>Market-open receipt and P&amp;L will replace this proof point only after real execution.</a:t>
+              <a:t>No candidate cleared every evidence, liquidity and risk gate. Thresholds stayed fixed.</a:t>
             </a:r>
           </a:p>
         </p:txBody>
@@ -6691,6 +6795,7 @@
           <a:lstStyle xmlns:a="http://schemas.openxmlformats.org/drawingml/2006/main"/>
           <a:p xmlns:a="http://schemas.openxmlformats.org/drawingml/2006/main">
             <a:pPr algn="l">
+              <a:buNone/>
               <a:defRPr sz="1050" b="1">
                 <a:solidFill>
                   <a:srgbClr val="147A46"/>
@@ -6741,6 +6846,7 @@
           <a:lstStyle xmlns:a="http://schemas.openxmlformats.org/drawingml/2006/main"/>
           <a:p xmlns:a="http://schemas.openxmlformats.org/drawingml/2006/main">
             <a:pPr algn="l">
+              <a:buNone/>
               <a:defRPr sz="3300" b="1">
                 <a:solidFill>
                   <a:srgbClr val="172019"/>
@@ -6753,7 +6859,7 @@
                   <a:srgbClr val="172019"/>
                 </a:solidFill>
               </a:rPr>
-              <a:t>Failure safety is part of the strategy.</a:t>
+              <a:t>Failure safety is observable - not silent.</a:t>
             </a:r>
           </a:p>
         </p:txBody>
@@ -6822,6 +6928,7 @@
           <a:lstStyle xmlns:a="http://schemas.openxmlformats.org/drawingml/2006/main"/>
           <a:p xmlns:a="http://schemas.openxmlformats.org/drawingml/2006/main">
             <a:pPr algn="r">
+              <a:buNone/>
               <a:defRPr sz="975" b="1">
                 <a:solidFill>
                   <a:srgbClr val="68736D"/>
@@ -6872,6 +6979,7 @@
           <a:lstStyle xmlns:a="http://schemas.openxmlformats.org/drawingml/2006/main"/>
           <a:p xmlns:a="http://schemas.openxmlformats.org/drawingml/2006/main">
             <a:pPr algn="l">
+              <a:buNone/>
               <a:defRPr sz="825" b="1">
                 <a:solidFill>
                   <a:srgbClr val="68736D"/>
@@ -6922,6 +7030,7 @@
           <a:lstStyle xmlns:a="http://schemas.openxmlformats.org/drawingml/2006/main"/>
           <a:p xmlns:a="http://schemas.openxmlformats.org/drawingml/2006/main">
             <a:pPr algn="l">
+              <a:buNone/>
               <a:defRPr sz="1500" b="1">
                 <a:solidFill>
                   <a:srgbClr val="147A46"/>
@@ -6934,7 +7043,7 @@
                   <a:srgbClr val="147A46"/>
                 </a:solidFill>
               </a:rPr>
-              <a:t>IDEMPOTENT</a:t>
+              <a:t>STRICT EVIDENCE</a:t>
             </a:r>
           </a:p>
         </p:txBody>
@@ -6972,6 +7081,7 @@
           <a:lstStyle xmlns:a="http://schemas.openxmlformats.org/drawingml/2006/main"/>
           <a:p xmlns:a="http://schemas.openxmlformats.org/drawingml/2006/main">
             <a:pPr algn="l">
+              <a:buNone/>
               <a:defRPr sz="1650" b="0">
                 <a:solidFill>
                   <a:srgbClr val="172019"/>
@@ -6984,7 +7094,7 @@
                   <a:srgbClr val="172019"/>
                 </a:solidFill>
               </a:rPr>
-              <a:t>Timeout → lookup by client_order_id → never blind retry</a:t>
+              <a:t>Strict schema; refusal, timeout or invalid output -&gt; ABSTAIN</a:t>
             </a:r>
           </a:p>
         </p:txBody>
@@ -7022,6 +7132,7 @@
           <a:lstStyle xmlns:a="http://schemas.openxmlformats.org/drawingml/2006/main"/>
           <a:p xmlns:a="http://schemas.openxmlformats.org/drawingml/2006/main">
             <a:pPr algn="l">
+              <a:buNone/>
               <a:defRPr sz="1500" b="1">
                 <a:solidFill>
                   <a:srgbClr val="147A46"/>
@@ -7034,7 +7145,7 @@
                   <a:srgbClr val="147A46"/>
                 </a:solidFill>
               </a:rPr>
-              <a:t>APPEND-ONLY</a:t>
+              <a:t>IDEMPOTENT</a:t>
             </a:r>
           </a:p>
         </p:txBody>
@@ -7072,6 +7183,7 @@
           <a:lstStyle xmlns:a="http://schemas.openxmlformats.org/drawingml/2006/main"/>
           <a:p xmlns:a="http://schemas.openxmlformats.org/drawingml/2006/main">
             <a:pPr algn="l">
+              <a:buNone/>
               <a:defRPr sz="1650" b="0">
                 <a:solidFill>
                   <a:srgbClr val="172019"/>
@@ -7084,7 +7196,7 @@
                   <a:srgbClr val="172019"/>
                 </a:solidFill>
               </a:rPr>
-              <a:t>Service-role writes · anonymous reads · update/delete blocked</a:t>
+              <a:t>Deterministic ID; timeout -&gt; lookup, never blind retry</a:t>
             </a:r>
           </a:p>
         </p:txBody>
@@ -7122,6 +7234,7 @@
           <a:lstStyle xmlns:a="http://schemas.openxmlformats.org/drawingml/2006/main"/>
           <a:p xmlns:a="http://schemas.openxmlformats.org/drawingml/2006/main">
             <a:pPr algn="l">
+              <a:buNone/>
               <a:defRPr sz="1500" b="1">
                 <a:solidFill>
                   <a:srgbClr val="147A46"/>
@@ -7134,7 +7247,7 @@
                   <a:srgbClr val="147A46"/>
                 </a:solidFill>
               </a:rPr>
-              <a:t>FAIL-CLOSED</a:t>
+              <a:t>WATCHED + DIAGNOSED</a:t>
             </a:r>
           </a:p>
         </p:txBody>
@@ -7172,6 +7285,7 @@
           <a:lstStyle xmlns:a="http://schemas.openxmlformats.org/drawingml/2006/main"/>
           <a:p xmlns:a="http://schemas.openxmlformats.org/drawingml/2006/main">
             <a:pPr algn="l">
+              <a:buNone/>
               <a:defRPr sz="1650" b="0">
                 <a:solidFill>
                   <a:srgbClr val="172019"/>
@@ -7184,32 +7298,30 @@
                   <a:srgbClr val="172019"/>
                 </a:solidFill>
               </a:rPr>
-              <a:t>Invalid model output, stale market data or missing liquidity → ABSTAIN</a:t>
+              <a:t>Stale-run watchdog; sanitized option-stage failure codes</a:t>
             </a:r>
           </a:p>
         </p:txBody>
       </p:sp>
       <p:pic>
         <p:nvPicPr>
-          <p:cNvPr id="24" name=""/>
+          <p:cNvPr id="26" name=""/>
           <p:cNvPicPr>
             <a:picLocks xmlns:a="http://schemas.openxmlformats.org/drawingml/2006/main" noChangeAspect="1"/>
           </p:cNvPicPr>
           <p:nvPr/>
         </p:nvPicPr>
         <p:blipFill>
-          <a:blip xmlns:r="http://schemas.openxmlformats.org/officeDocument/2006/relationships" xmlns:a="http://schemas.openxmlformats.org/drawingml/2006/main" r:embed="R272207bb79264ed7"/>
+          <a:blip xmlns:r="http://schemas.openxmlformats.org/officeDocument/2006/relationships" xmlns:a="http://schemas.openxmlformats.org/drawingml/2006/main" r:embed="R16ab2cd9163e409b"/>
           <a:stretch xmlns:a="http://schemas.openxmlformats.org/drawingml/2006/main"/>
         </p:blipFill>
         <p:spPr>
-          <a:xfrm xmlns:a="http://schemas.openxmlformats.org/drawingml/2006/main">
+          <a:xfrm xmlns:a="http://schemas.openxmlformats.org/drawingml/2006/main" flipH="0" flipV="0">
             <a:off x="8106068" y="1962150"/>
             <a:ext cx="1980613" cy="4286250"/>
           </a:xfrm>
           <a:prstGeom xmlns:a="http://schemas.openxmlformats.org/drawingml/2006/main" prst="roundRect">
-            <a:avLst>
-              <a:gd name="adj" fmla="val 4103"/>
-            </a:avLst>
+            <a:avLst/>
           </a:prstGeom>
         </p:spPr>
       </p:pic>
@@ -7275,6 +7387,7 @@
           <a:lstStyle xmlns:a="http://schemas.openxmlformats.org/drawingml/2006/main"/>
           <a:p xmlns:a="http://schemas.openxmlformats.org/drawingml/2006/main">
             <a:pPr algn="l">
+              <a:buNone/>
               <a:defRPr sz="1050" b="1">
                 <a:solidFill>
                   <a:srgbClr val="147A46"/>
@@ -7287,7 +7400,7 @@
                   <a:srgbClr val="147A46"/>
                 </a:solidFill>
               </a:rPr>
-              <a:t>WHAT COMES NEXT</a:t>
+              <a:t>BUSINESS VALUE</a:t>
             </a:r>
           </a:p>
         </p:txBody>
@@ -7325,6 +7438,7 @@
           <a:lstStyle xmlns:a="http://schemas.openxmlformats.org/drawingml/2006/main"/>
           <a:p xmlns:a="http://schemas.openxmlformats.org/drawingml/2006/main">
             <a:pPr algn="l">
+              <a:buNone/>
               <a:defRPr sz="3300" b="1">
                 <a:solidFill>
                   <a:srgbClr val="172019"/>
@@ -7337,7 +7451,7 @@
                   <a:srgbClr val="172019"/>
                 </a:solidFill>
               </a:rPr>
-              <a:t>Market-open proof—not prettier mockups.</a:t>
+              <a:t>Trust is the product when an agent can abstain.</a:t>
             </a:r>
           </a:p>
         </p:txBody>
@@ -7406,6 +7520,7 @@
           <a:lstStyle xmlns:a="http://schemas.openxmlformats.org/drawingml/2006/main"/>
           <a:p xmlns:a="http://schemas.openxmlformats.org/drawingml/2006/main">
             <a:pPr algn="r">
+              <a:buNone/>
               <a:defRPr sz="975" b="1">
                 <a:solidFill>
                   <a:srgbClr val="68736D"/>
@@ -7456,6 +7571,7 @@
           <a:lstStyle xmlns:a="http://schemas.openxmlformats.org/drawingml/2006/main"/>
           <a:p xmlns:a="http://schemas.openxmlformats.org/drawingml/2006/main">
             <a:pPr algn="l">
+              <a:buNone/>
               <a:defRPr sz="825" b="1">
                 <a:solidFill>
                   <a:srgbClr val="68736D"/>
@@ -7506,6 +7622,7 @@
           <a:lstStyle xmlns:a="http://schemas.openxmlformats.org/drawingml/2006/main"/>
           <a:p xmlns:a="http://schemas.openxmlformats.org/drawingml/2006/main">
             <a:pPr algn="l">
+              <a:buNone/>
               <a:defRPr sz="2250" b="1">
                 <a:solidFill>
                   <a:srgbClr val="147A46"/>
@@ -7556,6 +7673,7 @@
           <a:lstStyle xmlns:a="http://schemas.openxmlformats.org/drawingml/2006/main"/>
           <a:p xmlns:a="http://schemas.openxmlformats.org/drawingml/2006/main">
             <a:pPr algn="l">
+              <a:buNone/>
               <a:defRPr sz="1875" b="1">
                 <a:solidFill>
                   <a:srgbClr val="172019"/>
@@ -7568,7 +7686,7 @@
                   <a:srgbClr val="172019"/>
                 </a:solidFill>
               </a:rPr>
-              <a:t>Full 5-symbol shadow trace</a:t>
+              <a:t>Users: quant researchers, risk reviewers, agent operators</a:t>
             </a:r>
           </a:p>
         </p:txBody>
@@ -7606,6 +7724,7 @@
           <a:lstStyle xmlns:a="http://schemas.openxmlformats.org/drawingml/2006/main"/>
           <a:p xmlns:a="http://schemas.openxmlformats.org/drawingml/2006/main">
             <a:pPr algn="l">
+              <a:buNone/>
               <a:defRPr sz="2250" b="1">
                 <a:solidFill>
                   <a:srgbClr val="147A46"/>
@@ -7656,6 +7775,7 @@
           <a:lstStyle xmlns:a="http://schemas.openxmlformats.org/drawingml/2006/main"/>
           <a:p xmlns:a="http://schemas.openxmlformats.org/drawingml/2006/main">
             <a:pPr algn="l">
+              <a:buNone/>
               <a:defRPr sz="1875" b="1">
                 <a:solidFill>
                   <a:srgbClr val="172019"/>
@@ -7668,7 +7788,7 @@
                   <a:srgbClr val="172019"/>
                 </a:solidFill>
               </a:rPr>
-              <a:t>One independently revalidated paper spread</a:t>
+              <a:t>Problem: opaque AI trades move capital without auditable evidence</a:t>
             </a:r>
           </a:p>
         </p:txBody>
@@ -7706,6 +7826,7 @@
           <a:lstStyle xmlns:a="http://schemas.openxmlformats.org/drawingml/2006/main"/>
           <a:p xmlns:a="http://schemas.openxmlformats.org/drawingml/2006/main">
             <a:pPr algn="l">
+              <a:buNone/>
               <a:defRPr sz="2250" b="1">
                 <a:solidFill>
                   <a:srgbClr val="147A46"/>
@@ -7756,6 +7877,7 @@
           <a:lstStyle xmlns:a="http://schemas.openxmlformats.org/drawingml/2006/main"/>
           <a:p xmlns:a="http://schemas.openxmlformats.org/drawingml/2006/main">
             <a:pPr algn="l">
+              <a:buNone/>
               <a:defRPr sz="1875" b="1">
                 <a:solidFill>
                   <a:srgbClr val="172019"/>
@@ -7768,7 +7890,7 @@
                   <a:srgbClr val="172019"/>
                 </a:solidFill>
               </a:rPr>
-              <a:t>Two sessions with honest P&amp;L and drawdown</a:t>
+              <a:t>Value: inspect fixed gates and abstain when inputs are weak</a:t>
             </a:r>
           </a:p>
         </p:txBody>
@@ -7837,6 +7959,7 @@
           <a:lstStyle xmlns:a="http://schemas.openxmlformats.org/drawingml/2006/main"/>
           <a:p xmlns:a="http://schemas.openxmlformats.org/drawingml/2006/main">
             <a:pPr algn="l">
+              <a:buNone/>
               <a:defRPr sz="1125" b="1">
                 <a:solidFill>
                   <a:srgbClr val="68736D"/>
@@ -7849,7 +7972,7 @@
                   <a:srgbClr val="68736D"/>
                 </a:solidFill>
               </a:rPr>
-              <a:t>P&amp;L PERFORMANCE</a:t>
+              <a:t>AUDIT BEFORE ORDER</a:t>
             </a:r>
           </a:p>
         </p:txBody>
@@ -7887,6 +8010,7 @@
           <a:lstStyle xmlns:a="http://schemas.openxmlformats.org/drawingml/2006/main"/>
           <a:p xmlns:a="http://schemas.openxmlformats.org/drawingml/2006/main">
             <a:pPr algn="l">
+              <a:buNone/>
               <a:defRPr sz="1125" b="1">
                 <a:solidFill>
                   <a:srgbClr val="68736D"/>
@@ -7899,7 +8023,7 @@
                   <a:srgbClr val="68736D"/>
                 </a:solidFill>
               </a:rPr>
-              <a:t>TECHNOLOGY</a:t>
+              <a:t>REPLAYABLE NO-TRADE</a:t>
             </a:r>
           </a:p>
         </p:txBody>
@@ -7937,6 +8061,7 @@
           <a:lstStyle xmlns:a="http://schemas.openxmlformats.org/drawingml/2006/main"/>
           <a:p xmlns:a="http://schemas.openxmlformats.org/drawingml/2006/main">
             <a:pPr algn="l">
+              <a:buNone/>
               <a:defRPr sz="1125" b="1">
                 <a:solidFill>
                   <a:srgbClr val="68736D"/>
@@ -7949,7 +8074,7 @@
                   <a:srgbClr val="68736D"/>
                 </a:solidFill>
               </a:rPr>
-              <a:t>ORIGINALITY</a:t>
+              <a:t>SEARCH, NOT SENTIMENT</a:t>
             </a:r>
           </a:p>
         </p:txBody>
@@ -7987,6 +8112,7 @@
           <a:lstStyle xmlns:a="http://schemas.openxmlformats.org/drawingml/2006/main"/>
           <a:p xmlns:a="http://schemas.openxmlformats.org/drawingml/2006/main">
             <a:pPr algn="l">
+              <a:buNone/>
               <a:defRPr sz="1125" b="1">
                 <a:solidFill>
                   <a:srgbClr val="68736D"/>
@@ -7999,7 +8125,7 @@
                   <a:srgbClr val="68736D"/>
                 </a:solidFill>
               </a:rPr>
-              <a:t>EXECUTION</a:t>
+              <a:t>PAPER-ONLY</a:t>
             </a:r>
           </a:p>
         </p:txBody>
@@ -8037,6 +8163,7 @@
           <a:lstStyle xmlns:a="http://schemas.openxmlformats.org/drawingml/2006/main"/>
           <a:p xmlns:a="http://schemas.openxmlformats.org/drawingml/2006/main">
             <a:pPr algn="l">
+              <a:buNone/>
               <a:defRPr sz="1800" b="1">
                 <a:solidFill>
                   <a:srgbClr val="147A46"/>

</xml_diff>

<commit_message>
docs: refresh product clarity submission assets
</commit_message>
<xml_diff>
--- a/submission/crowd-excess-pitch-deck.pptx
+++ b/submission/crowd-excess-pitch-deck.pptx
@@ -2,21 +2,21 @@
 <file path=ppt/presentation.xml><?xml version="1.0" encoding="utf-8"?>
 <p:presentation xmlns:p="http://schemas.openxmlformats.org/presentationml/2006/main">
   <p:sldMasterIdLst>
-    <p:sldMasterId xmlns:r="http://schemas.openxmlformats.org/officeDocument/2006/relationships" id="2147483648" r:id="R86bc34bce21a49b4"/>
+    <p:sldMasterId xmlns:r="http://schemas.openxmlformats.org/officeDocument/2006/relationships" id="2147483648" r:id="Ra410ffb1d9674cd8"/>
   </p:sldMasterIdLst>
   <p:notesMasterIdLst>
-    <p:notesMasterId xmlns:r="http://schemas.openxmlformats.org/officeDocument/2006/relationships" r:id="R1977725c05344582"/>
+    <p:notesMasterId xmlns:r="http://schemas.openxmlformats.org/officeDocument/2006/relationships" r:id="R2e2ea286462441c5"/>
   </p:notesMasterIdLst>
   <p:sldIdLst>
-    <p:sldId xmlns:r="http://schemas.openxmlformats.org/officeDocument/2006/relationships" id="256" r:id="R34e27ba0bd8343a9"/>
-    <p:sldId xmlns:r="http://schemas.openxmlformats.org/officeDocument/2006/relationships" id="257" r:id="R2b5d1aaec4ab4b5b"/>
-    <p:sldId xmlns:r="http://schemas.openxmlformats.org/officeDocument/2006/relationships" id="258" r:id="R7b99c392af06443e"/>
-    <p:sldId xmlns:r="http://schemas.openxmlformats.org/officeDocument/2006/relationships" id="259" r:id="R7fd25e90909b4279"/>
-    <p:sldId xmlns:r="http://schemas.openxmlformats.org/officeDocument/2006/relationships" id="260" r:id="Rdfaae9bb877a4515"/>
-    <p:sldId xmlns:r="http://schemas.openxmlformats.org/officeDocument/2006/relationships" id="261" r:id="Rab29d2e2851b4d03"/>
-    <p:sldId xmlns:r="http://schemas.openxmlformats.org/officeDocument/2006/relationships" id="262" r:id="Rb3d4cc14e6a546ac"/>
-    <p:sldId xmlns:r="http://schemas.openxmlformats.org/officeDocument/2006/relationships" id="263" r:id="Rcf3655dd4a9643b9"/>
-    <p:sldId xmlns:r="http://schemas.openxmlformats.org/officeDocument/2006/relationships" id="264" r:id="R3872e019cb2b459e"/>
+    <p:sldId xmlns:r="http://schemas.openxmlformats.org/officeDocument/2006/relationships" id="256" r:id="Rcae13656bcf346e2"/>
+    <p:sldId xmlns:r="http://schemas.openxmlformats.org/officeDocument/2006/relationships" id="257" r:id="R17b0e00ced264159"/>
+    <p:sldId xmlns:r="http://schemas.openxmlformats.org/officeDocument/2006/relationships" id="258" r:id="R6eb9e4336c984b42"/>
+    <p:sldId xmlns:r="http://schemas.openxmlformats.org/officeDocument/2006/relationships" id="259" r:id="R1351bff6e9c845bb"/>
+    <p:sldId xmlns:r="http://schemas.openxmlformats.org/officeDocument/2006/relationships" id="260" r:id="R29caf77aee9c4e4a"/>
+    <p:sldId xmlns:r="http://schemas.openxmlformats.org/officeDocument/2006/relationships" id="261" r:id="R2debbf20699a4eae"/>
+    <p:sldId xmlns:r="http://schemas.openxmlformats.org/officeDocument/2006/relationships" id="262" r:id="R8df5ae963e744614"/>
+    <p:sldId xmlns:r="http://schemas.openxmlformats.org/officeDocument/2006/relationships" id="263" r:id="R84d97d1297d941fc"/>
+    <p:sldId xmlns:r="http://schemas.openxmlformats.org/officeDocument/2006/relationships" id="264" r:id="R38168b604df64416"/>
   </p:sldIdLst>
   <p:sldSz cx="12192000" cy="6858000"/>
   <p:notesSz cx="6858000" cy="9144000"/>
@@ -805,7 +805,7 @@
           <a:lstStyle xmlns:a="http://schemas.openxmlformats.org/drawingml/2006/main"/>
           <a:p xmlns:a="http://schemas.openxmlformats.org/drawingml/2006/main">
             <a:r>
-              <a:t>Show the public Overview, then use Open latest sampled run to enter the immutable trace.</a:t>
+              <a:t>Show the product-first public Overview. The primary action pins the latest sampled immutable run instead of the newer closed-market check.</a:t>
             </a:r>
           </a:p>
           <a:p xmlns:a="http://schemas.openxmlformats.org/drawingml/2006/main">
@@ -985,7 +985,7 @@
           <a:lstStyle xmlns:a="http://schemas.openxmlformats.org/drawingml/2006/main"/>
           <a:p xmlns:a="http://schemas.openxmlformats.org/drawingml/2006/main">
             <a:r>
-              <a:t>State the verified result exactly: seven market-open shadow scans, five symbols each, no order and no position.</a:t>
+              <a:t>Seven market-open runs recorded 35 signal snapshots. Thirty snapshots contain OpenAI response IDs and input hashes; the first five are fail-closed evidence-unavailable records, not model assessments.</a:t>
             </a:r>
           </a:p>
           <a:p xmlns:a="http://schemas.openxmlformats.org/drawingml/2006/main">
@@ -1000,17 +1000,37 @@
           </a:p>
           <a:p xmlns:a="http://schemas.openxmlformats.org/drawingml/2006/main">
             <a:r>
-              <a:t>- https://crowd-excess-lab.vercel.app/api/v1/agent/runs</a:t>
-            </a:r>
-          </a:p>
-          <a:p xmlns:a="http://schemas.openxmlformats.org/drawingml/2006/main">
-            <a:r>
-              <a:t>- https://crowd-excess-lab.vercel.app/api/v1/portfolio</a:t>
-            </a:r>
-          </a:p>
-          <a:p xmlns:a="http://schemas.openxmlformats.org/drawingml/2006/main">
-            <a:r>
-              <a:t>- https://crowd-excess-lab.vercel.app/agent/runs/20260828T193701Z-b404b62a</a:t>
+              <a:t>- https://crowd-excess-lab.vercel.app/api/v1/agent/runs/20260828T150454Z-85f0a128</a:t>
+            </a:r>
+          </a:p>
+          <a:p xmlns:a="http://schemas.openxmlformats.org/drawingml/2006/main">
+            <a:r>
+              <a:t>- https://crowd-excess-lab.vercel.app/api/v1/agent/runs/20260828T161149Z-04953e31</a:t>
+            </a:r>
+          </a:p>
+          <a:p xmlns:a="http://schemas.openxmlformats.org/drawingml/2006/main">
+            <a:r>
+              <a:t>- https://crowd-excess-lab.vercel.app/api/v1/agent/runs/20260828T174442Z-d761e38b</a:t>
+            </a:r>
+          </a:p>
+          <a:p xmlns:a="http://schemas.openxmlformats.org/drawingml/2006/main">
+            <a:r>
+              <a:t>- https://crowd-excess-lab.vercel.app/api/v1/agent/runs/20260828T181028Z-2ca98cc2</a:t>
+            </a:r>
+          </a:p>
+          <a:p xmlns:a="http://schemas.openxmlformats.org/drawingml/2006/main">
+            <a:r>
+              <a:t>- https://crowd-excess-lab.vercel.app/api/v1/agent/runs/20260828T183549Z-4a24409b</a:t>
+            </a:r>
+          </a:p>
+          <a:p xmlns:a="http://schemas.openxmlformats.org/drawingml/2006/main">
+            <a:r>
+              <a:t>- https://crowd-excess-lab.vercel.app/api/v1/agent/runs/20260828T191143Z-73974777</a:t>
+            </a:r>
+          </a:p>
+          <a:p xmlns:a="http://schemas.openxmlformats.org/drawingml/2006/main">
+            <a:r>
+              <a:t>- https://crowd-excess-lab.vercel.app/api/v1/agent/runs/20260828T193701Z-b404b62a</a:t>
             </a:r>
           </a:p>
         </p:txBody>
@@ -1268,7 +1288,7 @@
   </p:cSld>
   <p:clrMap bg1="lt1" tx1="dk1" bg2="lt2" tx2="dk2" accent1="accent1" accent2="accent2" accent3="accent3" accent4="accent4" accent5="accent5" accent6="accent6" hlink="hlink" folHlink="folHlink"/>
   <p:sldLayoutIdLst>
-    <p:sldLayoutId xmlns:r="http://schemas.openxmlformats.org/officeDocument/2006/relationships" id="2147483649" r:id="R5c24486076624cac"/>
+    <p:sldLayoutId xmlns:r="http://schemas.openxmlformats.org/officeDocument/2006/relationships" id="2147483649" r:id="Re16a1967690f405d"/>
   </p:sldLayoutIdLst>
   <p:txStyles>
     <p:titleStyle>
@@ -1816,7 +1836,7 @@
           <p:nvPr/>
         </p:nvPicPr>
         <p:blipFill>
-          <a:blip xmlns:r="http://schemas.openxmlformats.org/officeDocument/2006/relationships" xmlns:a="http://schemas.openxmlformats.org/drawingml/2006/main" r:embed="R18dd498e454e4fc1"/>
+          <a:blip xmlns:r="http://schemas.openxmlformats.org/officeDocument/2006/relationships" xmlns:a="http://schemas.openxmlformats.org/drawingml/2006/main" r:embed="R90c84d34d3a54e56"/>
           <a:srcRect xmlns:a="http://schemas.openxmlformats.org/drawingml/2006/main" l="0" t="27" r="0" b="27"/>
           <a:stretch xmlns:a="http://schemas.openxmlformats.org/drawingml/2006/main">
             <a:fillRect l="0" t="0" r="0" b="0"/>
@@ -4545,7 +4565,7 @@
           <p:nvPr/>
         </p:nvPicPr>
         <p:blipFill>
-          <a:blip xmlns:r="http://schemas.openxmlformats.org/officeDocument/2006/relationships" xmlns:a="http://schemas.openxmlformats.org/drawingml/2006/main" r:embed="Rc669f431c5df46ab"/>
+          <a:blip xmlns:r="http://schemas.openxmlformats.org/officeDocument/2006/relationships" xmlns:a="http://schemas.openxmlformats.org/drawingml/2006/main" r:embed="Rceef3592ec9e424f"/>
           <a:stretch xmlns:a="http://schemas.openxmlformats.org/drawingml/2006/main"/>
         </p:blipFill>
         <p:spPr>
@@ -4655,7 +4675,7 @@
                   <a:srgbClr val="172019"/>
                 </a:solidFill>
               </a:rPr>
-              <a:t>Latest check</a:t>
+              <a:t>Product thesis</a:t>
             </a:r>
           </a:p>
         </p:txBody>
@@ -4757,7 +4777,7 @@
                   <a:srgbClr val="172019"/>
                 </a:solidFill>
               </a:rPr>
-              <a:t>Latest sampled run</a:t>
+              <a:t>Latest sampled verdict</a:t>
             </a:r>
           </a:p>
         </p:txBody>
@@ -4859,7 +4879,7 @@
                   <a:srgbClr val="172019"/>
                 </a:solidFill>
               </a:rPr>
-              <a:t>Evidence -&gt; risk -&gt; outcome</a:t>
+              <a:t>Review the evidence</a:t>
             </a:r>
           </a:p>
         </p:txBody>
@@ -6438,7 +6458,7 @@
                   <a:srgbClr val="68736D"/>
                 </a:solidFill>
               </a:rPr>
-              <a:t>35 structured evidence assessments</a:t>
+              <a:t>35 signal snapshots | 30 model assessments</a:t>
             </a:r>
           </a:p>
         </p:txBody>
@@ -7312,7 +7332,7 @@
           <p:nvPr/>
         </p:nvPicPr>
         <p:blipFill>
-          <a:blip xmlns:r="http://schemas.openxmlformats.org/officeDocument/2006/relationships" xmlns:a="http://schemas.openxmlformats.org/drawingml/2006/main" r:embed="R16ab2cd9163e409b"/>
+          <a:blip xmlns:r="http://schemas.openxmlformats.org/officeDocument/2006/relationships" xmlns:a="http://schemas.openxmlformats.org/drawingml/2006/main" r:embed="Raa61f7c527894282"/>
           <a:stretch xmlns:a="http://schemas.openxmlformats.org/drawingml/2006/main"/>
         </p:blipFill>
         <p:spPr>

</xml_diff>

<commit_message>
docs: finalize two-session submission package
</commit_message>
<xml_diff>
--- a/submission/crowd-excess-pitch-deck.pptx
+++ b/submission/crowd-excess-pitch-deck.pptx
@@ -2,21 +2,21 @@
 <file path=ppt/presentation.xml><?xml version="1.0" encoding="utf-8"?>
 <p:presentation xmlns:p="http://schemas.openxmlformats.org/presentationml/2006/main">
   <p:sldMasterIdLst>
-    <p:sldMasterId xmlns:r="http://schemas.openxmlformats.org/officeDocument/2006/relationships" id="2147483648" r:id="Ra410ffb1d9674cd8"/>
+    <p:sldMasterId xmlns:r="http://schemas.openxmlformats.org/officeDocument/2006/relationships" id="2147483648" r:id="R0b3df5eb4b554c3e"/>
   </p:sldMasterIdLst>
   <p:notesMasterIdLst>
-    <p:notesMasterId xmlns:r="http://schemas.openxmlformats.org/officeDocument/2006/relationships" r:id="R2e2ea286462441c5"/>
+    <p:notesMasterId xmlns:r="http://schemas.openxmlformats.org/officeDocument/2006/relationships" r:id="Reec87fc34b5d40da"/>
   </p:notesMasterIdLst>
   <p:sldIdLst>
-    <p:sldId xmlns:r="http://schemas.openxmlformats.org/officeDocument/2006/relationships" id="256" r:id="Rcae13656bcf346e2"/>
-    <p:sldId xmlns:r="http://schemas.openxmlformats.org/officeDocument/2006/relationships" id="257" r:id="R17b0e00ced264159"/>
-    <p:sldId xmlns:r="http://schemas.openxmlformats.org/officeDocument/2006/relationships" id="258" r:id="R6eb9e4336c984b42"/>
-    <p:sldId xmlns:r="http://schemas.openxmlformats.org/officeDocument/2006/relationships" id="259" r:id="R1351bff6e9c845bb"/>
-    <p:sldId xmlns:r="http://schemas.openxmlformats.org/officeDocument/2006/relationships" id="260" r:id="R29caf77aee9c4e4a"/>
-    <p:sldId xmlns:r="http://schemas.openxmlformats.org/officeDocument/2006/relationships" id="261" r:id="R2debbf20699a4eae"/>
-    <p:sldId xmlns:r="http://schemas.openxmlformats.org/officeDocument/2006/relationships" id="262" r:id="R8df5ae963e744614"/>
-    <p:sldId xmlns:r="http://schemas.openxmlformats.org/officeDocument/2006/relationships" id="263" r:id="R84d97d1297d941fc"/>
-    <p:sldId xmlns:r="http://schemas.openxmlformats.org/officeDocument/2006/relationships" id="264" r:id="R38168b604df64416"/>
+    <p:sldId xmlns:r="http://schemas.openxmlformats.org/officeDocument/2006/relationships" id="256" r:id="R356127a8f02447be"/>
+    <p:sldId xmlns:r="http://schemas.openxmlformats.org/officeDocument/2006/relationships" id="257" r:id="R78164b4deb054981"/>
+    <p:sldId xmlns:r="http://schemas.openxmlformats.org/officeDocument/2006/relationships" id="258" r:id="R666f00bfcb774f81"/>
+    <p:sldId xmlns:r="http://schemas.openxmlformats.org/officeDocument/2006/relationships" id="259" r:id="R1f04490846944582"/>
+    <p:sldId xmlns:r="http://schemas.openxmlformats.org/officeDocument/2006/relationships" id="260" r:id="Raa35f56252214b28"/>
+    <p:sldId xmlns:r="http://schemas.openxmlformats.org/officeDocument/2006/relationships" id="261" r:id="Ra92533e75e25481b"/>
+    <p:sldId xmlns:r="http://schemas.openxmlformats.org/officeDocument/2006/relationships" id="262" r:id="R54242fc06c124676"/>
+    <p:sldId xmlns:r="http://schemas.openxmlformats.org/officeDocument/2006/relationships" id="263" r:id="R91aed9d7d4294835"/>
+    <p:sldId xmlns:r="http://schemas.openxmlformats.org/officeDocument/2006/relationships" id="264" r:id="Rc58076d4ebd04ca4"/>
   </p:sldIdLst>
   <p:sldSz cx="12192000" cy="6858000"/>
   <p:notesSz cx="6858000" cy="9144000"/>
@@ -985,7 +985,7 @@
           <a:lstStyle xmlns:a="http://schemas.openxmlformats.org/drawingml/2006/main"/>
           <a:p xmlns:a="http://schemas.openxmlformats.org/drawingml/2006/main">
             <a:r>
-              <a:t>Seven market-open runs recorded 35 signal snapshots. Thirty snapshots contain OpenAI response IDs and input hashes; the first five are fail-closed evidence-unavailable records, not model assessments.</a:t>
+              <a:t>Seventeen sampled runs across two US market dates recorded 85 signal snapshots. Seventy-eight snapshots contain OpenAI response IDs and input hashes; seven are fail-closed evidence-unavailable records, not model assessments.</a:t>
             </a:r>
           </a:p>
           <a:p xmlns:a="http://schemas.openxmlformats.org/drawingml/2006/main">
@@ -1000,37 +1000,17 @@
           </a:p>
           <a:p xmlns:a="http://schemas.openxmlformats.org/drawingml/2006/main">
             <a:r>
-              <a:t>- https://crowd-excess-lab.vercel.app/api/v1/agent/runs/20260828T150454Z-85f0a128</a:t>
-            </a:r>
-          </a:p>
-          <a:p xmlns:a="http://schemas.openxmlformats.org/drawingml/2006/main">
-            <a:r>
-              <a:t>- https://crowd-excess-lab.vercel.app/api/v1/agent/runs/20260828T161149Z-04953e31</a:t>
-            </a:r>
-          </a:p>
-          <a:p xmlns:a="http://schemas.openxmlformats.org/drawingml/2006/main">
-            <a:r>
-              <a:t>- https://crowd-excess-lab.vercel.app/api/v1/agent/runs/20260828T174442Z-d761e38b</a:t>
-            </a:r>
-          </a:p>
-          <a:p xmlns:a="http://schemas.openxmlformats.org/drawingml/2006/main">
-            <a:r>
-              <a:t>- https://crowd-excess-lab.vercel.app/api/v1/agent/runs/20260828T181028Z-2ca98cc2</a:t>
-            </a:r>
-          </a:p>
-          <a:p xmlns:a="http://schemas.openxmlformats.org/drawingml/2006/main">
-            <a:r>
-              <a:t>- https://crowd-excess-lab.vercel.app/api/v1/agent/runs/20260828T183549Z-4a24409b</a:t>
-            </a:r>
-          </a:p>
-          <a:p xmlns:a="http://schemas.openxmlformats.org/drawingml/2006/main">
-            <a:r>
-              <a:t>- https://crowd-excess-lab.vercel.app/api/v1/agent/runs/20260828T191143Z-73974777</a:t>
-            </a:r>
-          </a:p>
-          <a:p xmlns:a="http://schemas.openxmlformats.org/drawingml/2006/main">
-            <a:r>
-              <a:t>- https://crowd-excess-lab.vercel.app/api/v1/agent/runs/20260828T193701Z-b404b62a</a:t>
+              <a:t>- https://crowd-excess-lab.vercel.app/api/v1/agent/runs</a:t>
+            </a:r>
+          </a:p>
+          <a:p xmlns:a="http://schemas.openxmlformats.org/drawingml/2006/main">
+            <a:r>
+              <a:t>- https://crowd-excess-lab.vercel.app/api/v1/agent/runs/20260831T195329Z-97994d47</a:t>
+            </a:r>
+          </a:p>
+          <a:p xmlns:a="http://schemas.openxmlformats.org/drawingml/2006/main">
+            <a:r>
+              <a:t>- https://crowd-excess-lab.vercel.app/api/v1/portfolio</a:t>
             </a:r>
           </a:p>
         </p:txBody>
@@ -1288,7 +1268,7 @@
   </p:cSld>
   <p:clrMap bg1="lt1" tx1="dk1" bg2="lt2" tx2="dk2" accent1="accent1" accent2="accent2" accent3="accent3" accent4="accent4" accent5="accent5" accent6="accent6" hlink="hlink" folHlink="folHlink"/>
   <p:sldLayoutIdLst>
-    <p:sldLayoutId xmlns:r="http://schemas.openxmlformats.org/officeDocument/2006/relationships" id="2147483649" r:id="Re16a1967690f405d"/>
+    <p:sldLayoutId xmlns:r="http://schemas.openxmlformats.org/officeDocument/2006/relationships" id="2147483649" r:id="R94a8013dd4584906"/>
   </p:sldLayoutIdLst>
   <p:txStyles>
     <p:titleStyle>
@@ -1836,7 +1816,7 @@
           <p:nvPr/>
         </p:nvPicPr>
         <p:blipFill>
-          <a:blip xmlns:r="http://schemas.openxmlformats.org/officeDocument/2006/relationships" xmlns:a="http://schemas.openxmlformats.org/drawingml/2006/main" r:embed="R90c84d34d3a54e56"/>
+          <a:blip xmlns:r="http://schemas.openxmlformats.org/officeDocument/2006/relationships" xmlns:a="http://schemas.openxmlformats.org/drawingml/2006/main" r:embed="R893ca21a89bd4bda"/>
           <a:srcRect xmlns:a="http://schemas.openxmlformats.org/drawingml/2006/main" l="0" t="27" r="0" b="27"/>
           <a:stretch xmlns:a="http://schemas.openxmlformats.org/drawingml/2006/main">
             <a:fillRect l="0" t="0" r="0" b="0"/>
@@ -4565,7 +4545,7 @@
           <p:nvPr/>
         </p:nvPicPr>
         <p:blipFill>
-          <a:blip xmlns:r="http://schemas.openxmlformats.org/officeDocument/2006/relationships" xmlns:a="http://schemas.openxmlformats.org/drawingml/2006/main" r:embed="Rceef3592ec9e424f"/>
+          <a:blip xmlns:r="http://schemas.openxmlformats.org/officeDocument/2006/relationships" xmlns:a="http://schemas.openxmlformats.org/drawingml/2006/main" r:embed="R3ccc4c2dbc884b47"/>
           <a:stretch xmlns:a="http://schemas.openxmlformats.org/drawingml/2006/main"/>
         </p:blipFill>
         <p:spPr>
@@ -6121,7 +6101,7 @@
                   <a:srgbClr val="172019"/>
                 </a:solidFill>
               </a:rPr>
-              <a:t>Seven market-open scans protected capital.</a:t>
+              <a:t>Two independent market sessions protected capital.</a:t>
             </a:r>
           </a:p>
         </p:txBody>
@@ -6172,7 +6152,7 @@
                   <a:srgbClr val="68736D"/>
                 </a:solidFill>
               </a:rPr>
-              <a:t>Competition evidence | 28 Aug 2026 US session</a:t>
+              <a:t>Competition evidence | 28 &amp; 31 Aug 2026 US sessions</a:t>
             </a:r>
           </a:p>
         </p:txBody>
@@ -6356,7 +6336,7 @@
                   <a:srgbClr val="855900"/>
                 </a:solidFill>
               </a:rPr>
-              <a:t>7 x 5</a:t>
+              <a:t>17 x 5</a:t>
             </a:r>
           </a:p>
         </p:txBody>
@@ -6458,7 +6438,7 @@
                   <a:srgbClr val="68736D"/>
                 </a:solidFill>
               </a:rPr>
-              <a:t>35 signal snapshots | 30 model assessments</a:t>
+              <a:t>85 signal snapshots | 78 model assessments</a:t>
             </a:r>
           </a:p>
         </p:txBody>
@@ -7332,7 +7312,7 @@
           <p:nvPr/>
         </p:nvPicPr>
         <p:blipFill>
-          <a:blip xmlns:r="http://schemas.openxmlformats.org/officeDocument/2006/relationships" xmlns:a="http://schemas.openxmlformats.org/drawingml/2006/main" r:embed="Raa61f7c527894282"/>
+          <a:blip xmlns:r="http://schemas.openxmlformats.org/officeDocument/2006/relationships" xmlns:a="http://schemas.openxmlformats.org/drawingml/2006/main" r:embed="R8e9ca154b1284903"/>
           <a:stretch xmlns:a="http://schemas.openxmlformats.org/drawingml/2006/main"/>
         </p:blipFill>
         <p:spPr>

</xml_diff>

<commit_message>
docs: center submission on crowd excess residual
</commit_message>
<xml_diff>
--- a/submission/crowd-excess-pitch-deck.pptx
+++ b/submission/crowd-excess-pitch-deck.pptx
@@ -2,21 +2,21 @@
 <file path=ppt/presentation.xml><?xml version="1.0" encoding="utf-8"?>
 <p:presentation xmlns:p="http://schemas.openxmlformats.org/presentationml/2006/main">
   <p:sldMasterIdLst>
-    <p:sldMasterId xmlns:r="http://schemas.openxmlformats.org/officeDocument/2006/relationships" id="2147483648" r:id="R0b3df5eb4b554c3e"/>
+    <p:sldMasterId xmlns:r="http://schemas.openxmlformats.org/officeDocument/2006/relationships" id="2147483648" r:id="Re6e8098521cb4a98"/>
   </p:sldMasterIdLst>
   <p:notesMasterIdLst>
-    <p:notesMasterId xmlns:r="http://schemas.openxmlformats.org/officeDocument/2006/relationships" r:id="Reec87fc34b5d40da"/>
+    <p:notesMasterId xmlns:r="http://schemas.openxmlformats.org/officeDocument/2006/relationships" r:id="R82836d045a014d14"/>
   </p:notesMasterIdLst>
   <p:sldIdLst>
-    <p:sldId xmlns:r="http://schemas.openxmlformats.org/officeDocument/2006/relationships" id="256" r:id="R356127a8f02447be"/>
-    <p:sldId xmlns:r="http://schemas.openxmlformats.org/officeDocument/2006/relationships" id="257" r:id="R78164b4deb054981"/>
-    <p:sldId xmlns:r="http://schemas.openxmlformats.org/officeDocument/2006/relationships" id="258" r:id="R666f00bfcb774f81"/>
-    <p:sldId xmlns:r="http://schemas.openxmlformats.org/officeDocument/2006/relationships" id="259" r:id="R1f04490846944582"/>
-    <p:sldId xmlns:r="http://schemas.openxmlformats.org/officeDocument/2006/relationships" id="260" r:id="Raa35f56252214b28"/>
-    <p:sldId xmlns:r="http://schemas.openxmlformats.org/officeDocument/2006/relationships" id="261" r:id="Ra92533e75e25481b"/>
-    <p:sldId xmlns:r="http://schemas.openxmlformats.org/officeDocument/2006/relationships" id="262" r:id="R54242fc06c124676"/>
-    <p:sldId xmlns:r="http://schemas.openxmlformats.org/officeDocument/2006/relationships" id="263" r:id="R91aed9d7d4294835"/>
-    <p:sldId xmlns:r="http://schemas.openxmlformats.org/officeDocument/2006/relationships" id="264" r:id="Rc58076d4ebd04ca4"/>
+    <p:sldId xmlns:r="http://schemas.openxmlformats.org/officeDocument/2006/relationships" id="256" r:id="Ra335297acd644265"/>
+    <p:sldId xmlns:r="http://schemas.openxmlformats.org/officeDocument/2006/relationships" id="257" r:id="Rcd08613ad81c4394"/>
+    <p:sldId xmlns:r="http://schemas.openxmlformats.org/officeDocument/2006/relationships" id="258" r:id="R960ee0b778b1418f"/>
+    <p:sldId xmlns:r="http://schemas.openxmlformats.org/officeDocument/2006/relationships" id="259" r:id="Ra9c101ef880a4818"/>
+    <p:sldId xmlns:r="http://schemas.openxmlformats.org/officeDocument/2006/relationships" id="260" r:id="R38fe6b79ca554877"/>
+    <p:sldId xmlns:r="http://schemas.openxmlformats.org/officeDocument/2006/relationships" id="261" r:id="Rca0cdd40df334550"/>
+    <p:sldId xmlns:r="http://schemas.openxmlformats.org/officeDocument/2006/relationships" id="262" r:id="Ra5f8e2939101421e"/>
+    <p:sldId xmlns:r="http://schemas.openxmlformats.org/officeDocument/2006/relationships" id="263" r:id="Rb76e64665b954527"/>
+    <p:sldId xmlns:r="http://schemas.openxmlformats.org/officeDocument/2006/relationships" id="264" r:id="Rb5425479333545d3"/>
   </p:sldIdLst>
   <p:sldSz cx="12192000" cy="6858000"/>
   <p:notesSz cx="6858000" cy="9144000"/>
@@ -805,7 +805,7 @@
           <a:lstStyle xmlns:a="http://schemas.openxmlformats.org/drawingml/2006/main"/>
           <a:p xmlns:a="http://schemas.openxmlformats.org/drawingml/2006/main">
             <a:r>
-              <a:t>Show the product-first public Overview. The primary action pins the latest sampled immutable run instead of the newer closed-market check.</a:t>
+              <a:t>Show the public Market Scan. The matrix makes attention, market-adjusted move, supplied-news evidence, and the final residual inspectable in one view.</a:t>
             </a:r>
           </a:p>
           <a:p xmlns:a="http://schemas.openxmlformats.org/drawingml/2006/main">
@@ -820,12 +820,7 @@
           </a:p>
           <a:p xmlns:a="http://schemas.openxmlformats.org/drawingml/2006/main">
             <a:r>
-              <a:t>- https://crowd-excess-lab.vercel.app/agent</a:t>
-            </a:r>
-          </a:p>
-          <a:p xmlns:a="http://schemas.openxmlformats.org/drawingml/2006/main">
-            <a:r>
-              <a:t>- https://crowd-excess-lab.vercel.app/decisions?run=20260828T193701Z-b404b62a</a:t>
+              <a:t>- https://crowd-excess-lab.vercel.app/decisions?run=20260831T195329Z-97994d47</a:t>
             </a:r>
           </a:p>
         </p:txBody>
@@ -1268,7 +1263,7 @@
   </p:cSld>
   <p:clrMap bg1="lt1" tx1="dk1" bg2="lt2" tx2="dk2" accent1="accent1" accent2="accent2" accent3="accent3" accent4="accent4" accent5="accent5" accent6="accent6" hlink="hlink" folHlink="folHlink"/>
   <p:sldLayoutIdLst>
-    <p:sldLayoutId xmlns:r="http://schemas.openxmlformats.org/officeDocument/2006/relationships" id="2147483649" r:id="R94a8013dd4584906"/>
+    <p:sldLayoutId xmlns:r="http://schemas.openxmlformats.org/officeDocument/2006/relationships" id="2147483649" r:id="R3e7cef77942341b6"/>
   </p:sldLayoutIdLst>
   <p:txStyles>
     <p:titleStyle>
@@ -1816,7 +1811,7 @@
           <p:nvPr/>
         </p:nvPicPr>
         <p:blipFill>
-          <a:blip xmlns:r="http://schemas.openxmlformats.org/officeDocument/2006/relationships" xmlns:a="http://schemas.openxmlformats.org/drawingml/2006/main" r:embed="R893ca21a89bd4bda"/>
+          <a:blip xmlns:r="http://schemas.openxmlformats.org/officeDocument/2006/relationships" xmlns:a="http://schemas.openxmlformats.org/drawingml/2006/main" r:embed="R4c641910a06c49dd"/>
           <a:srcRect xmlns:a="http://schemas.openxmlformats.org/drawingml/2006/main" l="0" t="27" r="0" b="27"/>
           <a:stretch xmlns:a="http://schemas.openxmlformats.org/drawingml/2006/main">
             <a:fillRect l="0" t="0" r="0" b="0"/>
@@ -4398,7 +4393,7 @@
                   <a:srgbClr val="172019"/>
                 </a:solidFill>
               </a:rPr>
-              <a:t>Every decision becomes an auditable trace.</a:t>
+              <a:t>The unexplained reaction is the product.</a:t>
             </a:r>
           </a:p>
         </p:txBody>
@@ -4545,7 +4540,7 @@
           <p:nvPr/>
         </p:nvPicPr>
         <p:blipFill>
-          <a:blip xmlns:r="http://schemas.openxmlformats.org/officeDocument/2006/relationships" xmlns:a="http://schemas.openxmlformats.org/drawingml/2006/main" r:embed="R3ccc4c2dbc884b47"/>
+          <a:blip xmlns:r="http://schemas.openxmlformats.org/officeDocument/2006/relationships" xmlns:a="http://schemas.openxmlformats.org/drawingml/2006/main" r:embed="R1d57448215c446fe"/>
           <a:stretch xmlns:a="http://schemas.openxmlformats.org/drawingml/2006/main"/>
         </p:blipFill>
         <p:spPr>
@@ -4655,7 +4650,7 @@
                   <a:srgbClr val="172019"/>
                 </a:solidFill>
               </a:rPr>
-              <a:t>Product thesis</a:t>
+              <a:t>Measure attention + move</a:t>
             </a:r>
           </a:p>
         </p:txBody>
@@ -4757,7 +4752,7 @@
                   <a:srgbClr val="172019"/>
                 </a:solidFill>
               </a:rPr>
-              <a:t>Latest sampled verdict</a:t>
+              <a:t>Test news evidence</a:t>
             </a:r>
           </a:p>
         </p:txBody>
@@ -4859,7 +4854,7 @@
                   <a:srgbClr val="172019"/>
                 </a:solidFill>
               </a:rPr>
-              <a:t>Review the evidence</a:t>
+              <a:t>Inspect the residual</a:t>
             </a:r>
           </a:p>
         </p:txBody>
@@ -7298,7 +7293,7 @@
                   <a:srgbClr val="172019"/>
                 </a:solidFill>
               </a:rPr>
-              <a:t>Stale-run watchdog; sanitized option-stage failure codes</a:t>
+              <a:t>Stale-run watchdog; option-stage diagnostics implemented + tested</a:t>
             </a:r>
           </a:p>
         </p:txBody>
@@ -7312,7 +7307,7 @@
           <p:nvPr/>
         </p:nvPicPr>
         <p:blipFill>
-          <a:blip xmlns:r="http://schemas.openxmlformats.org/officeDocument/2006/relationships" xmlns:a="http://schemas.openxmlformats.org/drawingml/2006/main" r:embed="R8e9ca154b1284903"/>
+          <a:blip xmlns:r="http://schemas.openxmlformats.org/officeDocument/2006/relationships" xmlns:a="http://schemas.openxmlformats.org/drawingml/2006/main" r:embed="Reeb468a61a08404f"/>
           <a:stretch xmlns:a="http://schemas.openxmlformats.org/drawingml/2006/main"/>
         </p:blipFill>
         <p:spPr>
@@ -7400,7 +7395,7 @@
                   <a:srgbClr val="147A46"/>
                 </a:solidFill>
               </a:rPr>
-              <a:t>BUSINESS VALUE</a:t>
+              <a:t>DIFFERENTIATION</a:t>
             </a:r>
           </a:p>
         </p:txBody>
@@ -7451,7 +7446,7 @@
                   <a:srgbClr val="172019"/>
                 </a:solidFill>
               </a:rPr>
-              <a:t>Trust is the product when an agent can abstain.</a:t>
+              <a:t>The product is the unexplained reaction.</a:t>
             </a:r>
           </a:p>
         </p:txBody>
@@ -7686,7 +7681,7 @@
                   <a:srgbClr val="172019"/>
                 </a:solidFill>
               </a:rPr>
-              <a:t>Users: quant researchers, risk reviewers, agent operators</a:t>
+              <a:t>Attention: cross-border search measures when the crowd heats up</a:t>
             </a:r>
           </a:p>
         </p:txBody>
@@ -7788,7 +7783,7 @@
                   <a:srgbClr val="172019"/>
                 </a:solidFill>
               </a:rPr>
-              <a:t>Problem: opaque AI trades move capital without auditable evidence</a:t>
+              <a:t>Reaction: SPY-adjusted price isolates what the market actually did</a:t>
             </a:r>
           </a:p>
         </p:txBody>
@@ -7890,7 +7885,7 @@
                   <a:srgbClr val="172019"/>
                 </a:solidFill>
               </a:rPr>
-              <a:t>Value: inspect fixed gates and abstain when inputs are weak</a:t>
+              <a:t>Residual: supplied news explains the move—or leaves Crowd Excess</a:t>
             </a:r>
           </a:p>
         </p:txBody>

</xml_diff>